<commit_message>
Fix Block 2 font issues - remove Calibri overrides
- Remove all explicit font.name = 'Calibri' settings for regular text
- Let VanillaCore.pptx template control fonts through layout inheritance
- Keep Consolas font ONLY for code blocks (Layout 9)
- Regenerate Block 2 presentation with 24 slides using proper font rules
- Create fix_block2_fonts.py script for template font compliance
- Professional appearance with template-controlled fonts
</commit_message>
<xml_diff>
--- a/presentations/powerpoint/block2-presentation.pptx
+++ b/presentations/powerpoint/block2-presentation.pptx
@@ -1441,6 +1441,146 @@
           <a:p>
             <a:r>
               <a:t>Die Patterns ergänzen sich perfekt: Komplexe Business-Domänen werden durch Pattern-Kombination beherrschbar. Factory + Decorator lösen gemeinsam das Problem der flexiblen Objektzusammensetzung.</a:t>
+            </a:r>
+          </a:p>
+        </p:txBody>
+      </p:sp>
+      <p:sp>
+        <p:nvSpPr>
+          <p:cNvPr id="4" name="Slide Number Placeholder 3"/>
+          <p:cNvSpPr>
+            <a:spLocks noGrp="1"/>
+          </p:cNvSpPr>
+          <p:nvPr>
+            <p:ph type="sldNum" idx="5" sz="quarter"/>
+          </p:nvPr>
+        </p:nvSpPr>
+        <p:spPr/>
+      </p:sp>
+    </p:spTree>
+  </p:cSld>
+  <p:clrMapOvr>
+    <a:masterClrMapping/>
+  </p:clrMapOvr>
+</p:notes>
+</file>
+
+<file path=ppt/notesSlides/notesSlide22.xml><?xml version="1.0" encoding="utf-8"?>
+<p:notes xmlns:a="http://schemas.openxmlformats.org/drawingml/2006/main" xmlns:p="http://schemas.openxmlformats.org/presentationml/2006/main" xmlns:r="http://schemas.openxmlformats.org/officeDocument/2006/relationships">
+  <p:cSld>
+    <p:spTree>
+      <p:nvGrpSpPr>
+        <p:cNvPr id="1" name=""/>
+        <p:cNvGrpSpPr/>
+        <p:nvPr/>
+      </p:nvGrpSpPr>
+      <p:grpSpPr>
+        <a:xfrm>
+          <a:off x="0" y="0"/>
+          <a:ext cx="0" cy="0"/>
+          <a:chOff x="0" y="0"/>
+          <a:chExt cx="0" cy="0"/>
+        </a:xfrm>
+      </p:grpSpPr>
+      <p:sp>
+        <p:nvSpPr>
+          <p:cNvPr id="2" name="Slide Image Placeholder 1"/>
+          <p:cNvSpPr>
+            <a:spLocks noGrp="1"/>
+          </p:cNvSpPr>
+          <p:nvPr>
+            <p:ph type="sldImg" idx="2"/>
+          </p:nvPr>
+        </p:nvSpPr>
+        <p:spPr/>
+      </p:sp>
+      <p:sp>
+        <p:nvSpPr>
+          <p:cNvPr id="3" name="Notes Placeholder 2"/>
+          <p:cNvSpPr>
+            <a:spLocks noGrp="1"/>
+          </p:cNvSpPr>
+          <p:nvPr>
+            <p:ph type="body" idx="3" sz="quarter"/>
+          </p:nvPr>
+        </p:nvSpPr>
+        <p:spPr/>
+        <p:txBody>
+          <a:bodyPr/>
+          <a:lstStyle/>
+          <a:p>
+            <a:r>
+              <a:t>Enterprise-Tauglichkeit erfordert mehr als Design Patterns: Monitoring, Resilience, Distributed Systems Patterns und observability sind kritisch für Production-Einsatz.</a:t>
+            </a:r>
+          </a:p>
+        </p:txBody>
+      </p:sp>
+      <p:sp>
+        <p:nvSpPr>
+          <p:cNvPr id="4" name="Slide Number Placeholder 3"/>
+          <p:cNvSpPr>
+            <a:spLocks noGrp="1"/>
+          </p:cNvSpPr>
+          <p:nvPr>
+            <p:ph type="sldNum" idx="5" sz="quarter"/>
+          </p:nvPr>
+        </p:nvSpPr>
+        <p:spPr/>
+      </p:sp>
+    </p:spTree>
+  </p:cSld>
+  <p:clrMapOvr>
+    <a:masterClrMapping/>
+  </p:clrMapOvr>
+</p:notes>
+</file>
+
+<file path=ppt/notesSlides/notesSlide23.xml><?xml version="1.0" encoding="utf-8"?>
+<p:notes xmlns:a="http://schemas.openxmlformats.org/drawingml/2006/main" xmlns:p="http://schemas.openxmlformats.org/presentationml/2006/main" xmlns:r="http://schemas.openxmlformats.org/officeDocument/2006/relationships">
+  <p:cSld>
+    <p:spTree>
+      <p:nvGrpSpPr>
+        <p:cNvPr id="1" name=""/>
+        <p:cNvGrpSpPr/>
+        <p:nvPr/>
+      </p:nvGrpSpPr>
+      <p:grpSpPr>
+        <a:xfrm>
+          <a:off x="0" y="0"/>
+          <a:ext cx="0" cy="0"/>
+          <a:chOff x="0" y="0"/>
+          <a:chExt cx="0" cy="0"/>
+        </a:xfrm>
+      </p:grpSpPr>
+      <p:sp>
+        <p:nvSpPr>
+          <p:cNvPr id="2" name="Slide Image Placeholder 1"/>
+          <p:cNvSpPr>
+            <a:spLocks noGrp="1"/>
+          </p:cNvSpPr>
+          <p:nvPr>
+            <p:ph type="sldImg" idx="2"/>
+          </p:nvPr>
+        </p:nvSpPr>
+        <p:spPr/>
+      </p:sp>
+      <p:sp>
+        <p:nvSpPr>
+          <p:cNvPr id="3" name="Notes Placeholder 2"/>
+          <p:cNvSpPr>
+            <a:spLocks noGrp="1"/>
+          </p:cNvSpPr>
+          <p:nvPr>
+            <p:ph type="body" idx="3" sz="quarter"/>
+          </p:nvPr>
+        </p:nvSpPr>
+        <p:spPr/>
+        <p:txBody>
+          <a:bodyPr/>
+          <a:lstStyle/>
+          <a:p>
+            <a:r>
+              <a:t>Block 2 zeigt: Structural Patterns sind nicht nur akademische Konzepte, sondern lösen reale Enterprise-Performance und -Wartungsprobleme. Die Kombination mehrerer Patterns ist oft mächtiger als einzelne Pattern-Anwendung.</a:t>
             </a:r>
           </a:p>
         </p:txBody>
@@ -6123,9 +6263,6 @@
           <a:lstStyle/>
           <a:p>
             <a:r>
-              <a:rPr sz="3200" b="1">
-                <a:latin typeface="Calibri"/>
-              </a:rPr>
               <a:t>Block 2: Structural Patterns</a:t>
             </a:r>
           </a:p>
@@ -6147,10 +6284,7 @@
           <a:lstStyle/>
           <a:p>
             <a:r>
-              <a:rPr sz="2400" b="0">
-                <a:latin typeface="Calibri"/>
-              </a:rPr>
-              <a:t>Design Patterns Workshop - Deutsche Telekom</a:t>
+              <a:t>Pattern Overview</a:t>
             </a:r>
           </a:p>
         </p:txBody>
@@ -6180,7 +6314,7 @@
             <a:spLocks noGrp="1"/>
           </p:cNvSpPr>
           <p:nvPr>
-            <p:ph type="ctrTitle"/>
+            <p:ph type="title"/>
           </p:nvPr>
         </p:nvSpPr>
         <p:spPr/>
@@ -6189,9 +6323,6 @@
           <a:lstStyle/>
           <a:p>
             <a:r>
-              <a:rPr sz="3600" b="1">
-                <a:latin typeface="Calibri"/>
-              </a:rPr>
               <a:t>Facade Pattern</a:t>
             </a:r>
           </a:p>
@@ -6199,19 +6330,146 @@
       </p:sp>
       <p:sp>
         <p:nvSpPr>
-          <p:cNvPr id="3" name="Subtitle 2"/>
-          <p:cNvSpPr>
-            <a:spLocks noGrp="1"/>
-          </p:cNvSpPr>
-          <p:nvPr>
-            <p:ph type="subTitle" idx="1"/>
+          <p:cNvPr id="3" name="Content Placeholder 2"/>
+          <p:cNvSpPr>
+            <a:spLocks noGrp="1"/>
+          </p:cNvSpPr>
+          <p:nvPr>
+            <p:ph idx="1"/>
           </p:nvPr>
         </p:nvSpPr>
         <p:spPr/>
         <p:txBody>
           <a:bodyPr/>
           <a:lstStyle/>
-          <a:p/>
+          <a:p>
+            <a:r>
+              <a:rPr sz="1400">
+                <a:latin typeface="Consolas"/>
+              </a:rPr>
+              <a:t>// Client-Albtraum: 15+ Service-Abhängigkeiten</a:t>
+            </a:r>
+          </a:p>
+          <a:p>
+            <a:r>
+              <a:rPr sz="1400">
+                <a:latin typeface="Consolas"/>
+              </a:rPr>
+              <a:t>public class TariffOrderClient {</a:t>
+            </a:r>
+          </a:p>
+          <a:p>
+            <a:r>
+              <a:rPr sz="1400">
+                <a:latin typeface="Consolas"/>
+              </a:rPr>
+              <a:t>    private TariffValidationService validation;</a:t>
+            </a:r>
+          </a:p>
+          <a:p>
+            <a:r>
+              <a:rPr sz="1400">
+                <a:latin typeface="Consolas"/>
+              </a:rPr>
+              <a:t>    private CustomerCreditCheckService creditCheck;</a:t>
+            </a:r>
+          </a:p>
+          <a:p>
+            <a:r>
+              <a:rPr sz="1400">
+                <a:latin typeface="Consolas"/>
+              </a:rPr>
+              <a:t>    private PricingService pricing;</a:t>
+            </a:r>
+          </a:p>
+          <a:p>
+            <a:r>
+              <a:rPr sz="1400">
+                <a:latin typeface="Consolas"/>
+              </a:rPr>
+              <a:t>    private InventoryService inventory;</a:t>
+            </a:r>
+          </a:p>
+          <a:p>
+            <a:r>
+              <a:rPr sz="1400">
+                <a:latin typeface="Consolas"/>
+              </a:rPr>
+              <a:t>    private NotificationService notification;</a:t>
+            </a:r>
+          </a:p>
+          <a:p>
+            <a:r>
+              <a:rPr sz="1400">
+                <a:latin typeface="Consolas"/>
+              </a:rPr>
+              <a:t>    // ... 10 weitere Services</a:t>
+            </a:r>
+          </a:p>
+          <a:p>
+            <a:r>
+              <a:rPr sz="1400">
+                <a:latin typeface="Consolas"/>
+              </a:rPr>
+              <a:t>    public void createOrder(TariffRequest request) {</a:t>
+            </a:r>
+          </a:p>
+          <a:p>
+            <a:r>
+              <a:rPr sz="1400">
+                <a:latin typeface="Consolas"/>
+              </a:rPr>
+              <a:t>        // 50+ Zeilen Orchestrierung</a:t>
+            </a:r>
+          </a:p>
+          <a:p>
+            <a:r>
+              <a:rPr sz="1400">
+                <a:latin typeface="Consolas"/>
+              </a:rPr>
+              <a:t>        if (validation.check() &amp;&amp; creditCheck.approve() &amp;&amp; </a:t>
+            </a:r>
+          </a:p>
+          <a:p>
+            <a:r>
+              <a:rPr sz="1400">
+                <a:latin typeface="Consolas"/>
+              </a:rPr>
+              <a:t>            pricing.calculate() &amp;&amp; inventory.reserve()) {</a:t>
+            </a:r>
+          </a:p>
+          <a:p>
+            <a:r>
+              <a:rPr sz="1400">
+                <a:latin typeface="Consolas"/>
+              </a:rPr>
+              <a:t>            // Komplexe If-Verschachtelung</a:t>
+            </a:r>
+          </a:p>
+          <a:p>
+            <a:r>
+              <a:rPr sz="1400">
+                <a:latin typeface="Consolas"/>
+              </a:rPr>
+              <a:t>        }</a:t>
+            </a:r>
+          </a:p>
+          <a:p>
+            <a:r>
+              <a:rPr sz="1400">
+                <a:latin typeface="Consolas"/>
+              </a:rPr>
+              <a:t>    }</a:t>
+            </a:r>
+          </a:p>
+          <a:p>
+            <a:r>
+              <a:rPr sz="1400">
+                <a:latin typeface="Consolas"/>
+              </a:rPr>
+              <a:t>}</a:t>
+            </a:r>
+          </a:p>
         </p:txBody>
       </p:sp>
     </p:spTree>
@@ -6248,10 +6506,7 @@
           <a:lstStyle/>
           <a:p>
             <a:r>
-              <a:rPr sz="2800" b="1">
-                <a:latin typeface="Calibri"/>
-              </a:rPr>
-              <a:t>Code Smells identifiziert</a:t>
+              <a:t>Slide 10: Code Smells identifiziert</a:t>
             </a:r>
           </a:p>
         </p:txBody>
@@ -6271,66 +6526,38 @@
           <a:bodyPr/>
           <a:lstStyle/>
           <a:p>
-            <a:pPr/>
-            <a:r>
-              <a:rPr sz="1600">
-                <a:latin typeface="Calibri"/>
-              </a:rPr>
-              <a:t>**Abhängigkeits-Explosion**: Client kennt 15+ Services intimement</a:t>
-            </a:r>
-          </a:p>
-          <a:p>
-            <a:pPr/>
-            <a:r>
-              <a:rPr sz="1600">
-                <a:latin typeface="Calibri"/>
-              </a:rPr>
-              <a:t>**Orchestrierungs-Komplexität**: 50+ Zeilen if/else-Logik pro Use Case</a:t>
-            </a:r>
-          </a:p>
-          <a:p>
-            <a:pPr/>
-            <a:r>
-              <a:rPr sz="1600">
-                <a:latin typeface="Calibri"/>
-              </a:rPr>
-              <a:t>**Fehlerbehandlungs-Chaos**: Exponentiell wachsende Fehlerpfade</a:t>
-            </a:r>
-          </a:p>
-          <a:p>
-            <a:pPr/>
-            <a:r>
-              <a:rPr sz="1600">
-                <a:latin typeface="Calibri"/>
-              </a:rPr>
-              <a:t>**Testing-Alptraum**: Mocking von 15+ Services pro Unit Test</a:t>
-            </a:r>
-          </a:p>
-          <a:p>
-            <a:pPr/>
-            <a:r>
-              <a:rPr sz="1600">
-                <a:latin typeface="Calibri"/>
-              </a:rPr>
-              <a:t>**Deployment-Fragilität**: Client bricht bei jeder Service-Änderung</a:t>
-            </a:r>
-          </a:p>
-          <a:p>
-            <a:pPr/>
-            <a:r>
-              <a:rPr sz="1600">
-                <a:latin typeface="Calibri"/>
-              </a:rPr>
-              <a:t>**Code-Duplikation**: Gleiche Orchestrierung in mehreren Clients</a:t>
-            </a:r>
-          </a:p>
-          <a:p>
-            <a:pPr/>
-            <a:r>
-              <a:rPr sz="1600">
-                <a:latin typeface="Calibri"/>
-              </a:rPr>
-              <a:t>**Service-Interface-Leakage**: Interne Service-Details überall sichtbar</a:t>
+            <a:r>
+              <a:t>Abhängigkeits-Explosion**: Client kennt 15+ Services intimement</a:t>
+            </a:r>
+          </a:p>
+          <a:p>
+            <a:r>
+              <a:t>Orchestrierungs-Komplexität**: 50+ Zeilen if/else-Logik pro Use Case</a:t>
+            </a:r>
+          </a:p>
+          <a:p>
+            <a:r>
+              <a:t>Fehlerbehandlungs-Chaos**: Exponentiell wachsende Fehlerpfade</a:t>
+            </a:r>
+          </a:p>
+          <a:p>
+            <a:r>
+              <a:t>Testing-Alptraum**: Mocking von 15+ Services pro Unit Test</a:t>
+            </a:r>
+          </a:p>
+          <a:p>
+            <a:r>
+              <a:t>Deployment-Fragilität**: Client bricht bei jeder Service-Änderung</a:t>
+            </a:r>
+          </a:p>
+          <a:p>
+            <a:r>
+              <a:t>Code-Duplikation**: Gleiche Orchestrierung in mehreren Clients</a:t>
+            </a:r>
+          </a:p>
+          <a:p>
+            <a:r>
+              <a:t>Service-Interface-Leakage**: Interne Service-Details überall sichtbar</a:t>
             </a:r>
           </a:p>
         </p:txBody>
@@ -6369,10 +6596,7 @@
           <a:lstStyle/>
           <a:p>
             <a:r>
-              <a:rPr sz="2800" b="1">
-                <a:latin typeface="Calibri"/>
-              </a:rPr>
-              <a:t>Lösung: Facade Pattern</a:t>
+              <a:t>Slide 11: Lösung: Facade Pattern</a:t>
             </a:r>
           </a:p>
         </p:txBody>
@@ -6392,66 +6616,38 @@
           <a:bodyPr/>
           <a:lstStyle/>
           <a:p>
-            <a:pPr/>
-            <a:r>
-              <a:rPr sz="1600">
-                <a:latin typeface="Calibri"/>
-              </a:rPr>
-              <a:t>**Einheitliche Schnittstelle**: Eine einfache API vor komplexem Subsystem</a:t>
-            </a:r>
-          </a:p>
-          <a:p>
-            <a:pPr/>
-            <a:r>
-              <a:rPr sz="1600">
-                <a:latin typeface="Calibri"/>
-              </a:rPr>
-              <a:t>**Komplexitäts-Kapselung**: Interne Orchestrierung für Clients unsichtbar</a:t>
-            </a:r>
-          </a:p>
-          <a:p>
-            <a:pPr/>
-            <a:r>
-              <a:rPr sz="1600">
-                <a:latin typeface="Calibri"/>
-              </a:rPr>
-              <a:t>**Use-Case-spezifische APIs**: APIs sprechen die Sprache der Business-User</a:t>
-            </a:r>
-          </a:p>
-          <a:p>
-            <a:pPr/>
-            <a:r>
-              <a:rPr sz="1600">
-                <a:latin typeface="Calibri"/>
-              </a:rPr>
-              <a:t>**Zentrale Fehlerbehandlung**: Standardisierte Error-Responses</a:t>
-            </a:r>
-          </a:p>
-          <a:p>
-            <a:pPr/>
-            <a:r>
-              <a:rPr sz="1600">
-                <a:latin typeface="Calibri"/>
-              </a:rPr>
-              <a:t>**Versionierungs-Puffer**: API-Änderungen ohne Client-Brüche möglich</a:t>
-            </a:r>
-          </a:p>
-          <a:p>
-            <a:pPr/>
-            <a:r>
-              <a:rPr sz="1600">
-                <a:latin typeface="Calibri"/>
-              </a:rPr>
-              <a:t>**Performance-Optimierung**: Parallelisierung und Caching zentral möglich</a:t>
-            </a:r>
-          </a:p>
-          <a:p>
-            <a:pPr/>
-            <a:r>
-              <a:rPr sz="1600">
-                <a:latin typeface="Calibri"/>
-              </a:rPr>
-              <a:t>**Service-Abstraktion**: Services können ausgetauscht werden ohne Client-Impact</a:t>
+            <a:r>
+              <a:t>Einheitliche Schnittstelle**: Eine einfache API vor komplexem Subsystem</a:t>
+            </a:r>
+          </a:p>
+          <a:p>
+            <a:r>
+              <a:t>Komplexitäts-Kapselung**: Interne Orchestrierung für Clients unsichtbar</a:t>
+            </a:r>
+          </a:p>
+          <a:p>
+            <a:r>
+              <a:t>Use-Case-spezifische APIs**: APIs sprechen die Sprache der Business-User</a:t>
+            </a:r>
+          </a:p>
+          <a:p>
+            <a:r>
+              <a:t>Zentrale Fehlerbehandlung**: Standardisierte Error-Responses</a:t>
+            </a:r>
+          </a:p>
+          <a:p>
+            <a:r>
+              <a:t>Versionierungs-Puffer**: API-Änderungen ohne Client-Brüche möglich</a:t>
+            </a:r>
+          </a:p>
+          <a:p>
+            <a:r>
+              <a:t>Performance-Optimierung**: Parallelisierung und Caching zentral möglich</a:t>
+            </a:r>
+          </a:p>
+          <a:p>
+            <a:r>
+              <a:t>Service-Abstraktion**: Services können ausgetauscht werden ohne Client-Impact</a:t>
             </a:r>
           </a:p>
         </p:txBody>
@@ -6490,10 +6686,7 @@
           <a:lstStyle/>
           <a:p>
             <a:r>
-              <a:rPr sz="2800" b="1">
-                <a:latin typeface="Calibri"/>
-              </a:rPr>
-              <a:t>Implementierung</a:t>
+              <a:t>Slide 12: Implementierung</a:t>
             </a:r>
           </a:p>
         </p:txBody>
@@ -6510,402 +6703,171 @@
         </p:nvSpPr>
         <p:spPr/>
         <p:txBody>
-          <a:bodyPr tIns="91440" bIns="91440"/>
+          <a:bodyPr/>
           <a:lstStyle/>
           <a:p>
-            <a:pPr>
-              <a:lnSpc>
-                <a:spcPct val="100000"/>
-              </a:lnSpc>
-              <a:spcBef>
-                <a:spcPts val="0"/>
-              </a:spcBef>
-              <a:spcAft>
-                <a:spcPts val="0"/>
-              </a:spcAft>
-            </a:pPr>
-            <a:r>
-              <a:rPr sz="1200">
+            <a:r>
+              <a:rPr sz="1400">
                 <a:latin typeface="Consolas"/>
               </a:rPr>
               <a:t>@Service</a:t>
             </a:r>
           </a:p>
           <a:p>
-            <a:pPr>
-              <a:lnSpc>
-                <a:spcPct val="100000"/>
-              </a:lnSpc>
-              <a:spcBef>
-                <a:spcPts val="0"/>
-              </a:spcBef>
-              <a:spcAft>
-                <a:spcPts val="0"/>
-              </a:spcAft>
-            </a:pPr>
-            <a:r>
-              <a:rPr sz="1200">
+            <a:r>
+              <a:rPr sz="1400">
                 <a:latin typeface="Consolas"/>
               </a:rPr>
               <a:t>public class TariffOrderFacade {</a:t>
             </a:r>
           </a:p>
           <a:p>
-            <a:pPr>
-              <a:lnSpc>
-                <a:spcPct val="100000"/>
-              </a:lnSpc>
-              <a:spcBef>
-                <a:spcPts val="0"/>
-              </a:spcBef>
-              <a:spcAft>
-                <a:spcPts val="0"/>
-              </a:spcAft>
-            </a:pPr>
-            <a:r>
-              <a:rPr sz="1200">
+            <a:r>
+              <a:rPr sz="1400">
                 <a:latin typeface="Consolas"/>
               </a:rPr>
               <a:t>    // Alle komplexen Dependencies sind privat gekapselt</a:t>
             </a:r>
           </a:p>
           <a:p>
-            <a:pPr>
-              <a:lnSpc>
-                <a:spcPct val="100000"/>
-              </a:lnSpc>
-              <a:spcBef>
-                <a:spcPts val="0"/>
-              </a:spcBef>
-              <a:spcAft>
-                <a:spcPts val="0"/>
-              </a:spcAft>
-            </a:pPr>
-            <a:r>
-              <a:rPr sz="1200">
+            <a:r>
+              <a:rPr sz="1400">
                 <a:latin typeface="Consolas"/>
               </a:rPr>
               <a:t>    private final TariffValidationService validation;</a:t>
             </a:r>
           </a:p>
           <a:p>
-            <a:pPr>
-              <a:lnSpc>
-                <a:spcPct val="100000"/>
-              </a:lnSpc>
-              <a:spcBef>
-                <a:spcPts val="0"/>
-              </a:spcBef>
-              <a:spcAft>
-                <a:spcPts val="0"/>
-              </a:spcAft>
-            </a:pPr>
-            <a:r>
-              <a:rPr sz="1200">
+            <a:r>
+              <a:rPr sz="1400">
                 <a:latin typeface="Consolas"/>
               </a:rPr>
               <a:t>    private final CreditCheckService creditCheck;</a:t>
             </a:r>
           </a:p>
           <a:p>
-            <a:pPr>
-              <a:lnSpc>
-                <a:spcPct val="100000"/>
-              </a:lnSpc>
-              <a:spcBef>
-                <a:spcPts val="0"/>
-              </a:spcBef>
-              <a:spcAft>
-                <a:spcPts val="0"/>
-              </a:spcAft>
-            </a:pPr>
-            <a:r>
-              <a:rPr sz="1200">
+            <a:r>
+              <a:rPr sz="1400">
                 <a:latin typeface="Consolas"/>
               </a:rPr>
               <a:t>    // ... weitere Services (privat!)</a:t>
             </a:r>
           </a:p>
           <a:p>
-            <a:pPr>
-              <a:lnSpc>
-                <a:spcPct val="100000"/>
-              </a:lnSpc>
-              <a:spcBef>
-                <a:spcPts val="0"/>
-              </a:spcBef>
-              <a:spcAft>
-                <a:spcPts val="0"/>
-              </a:spcAft>
-            </a:pPr>
-            <a:r>
-              <a:rPr sz="1200">
+            <a:r>
+              <a:rPr sz="1400">
                 <a:latin typeface="Consolas"/>
               </a:rPr>
               <a:t>    public TariffOrderResult createTariffOrder(TariffOrderRequest request) {</a:t>
             </a:r>
           </a:p>
           <a:p>
-            <a:pPr>
-              <a:lnSpc>
-                <a:spcPct val="100000"/>
-              </a:lnSpc>
-              <a:spcBef>
-                <a:spcPts val="0"/>
-              </a:spcBef>
-              <a:spcAft>
-                <a:spcPts val="0"/>
-              </a:spcAft>
-            </a:pPr>
-            <a:r>
-              <a:rPr sz="1200">
+            <a:r>
+              <a:rPr sz="1400">
                 <a:latin typeface="Consolas"/>
               </a:rPr>
               <a:t>        try {</a:t>
             </a:r>
           </a:p>
           <a:p>
-            <a:pPr>
-              <a:lnSpc>
-                <a:spcPct val="100000"/>
-              </a:lnSpc>
-              <a:spcBef>
-                <a:spcPts val="0"/>
-              </a:spcBef>
-              <a:spcAft>
-                <a:spcPts val="0"/>
-              </a:spcAft>
-            </a:pPr>
-            <a:r>
-              <a:rPr sz="1200">
+            <a:r>
+              <a:rPr sz="1400">
                 <a:latin typeface="Consolas"/>
               </a:rPr>
               <a:t>            if (!validateOrder(request).isValid()) {</a:t>
             </a:r>
           </a:p>
           <a:p>
-            <a:pPr>
-              <a:lnSpc>
-                <a:spcPct val="100000"/>
-              </a:lnSpc>
-              <a:spcBef>
-                <a:spcPts val="0"/>
-              </a:spcBef>
-              <a:spcAft>
-                <a:spcPts val="0"/>
-              </a:spcAft>
-            </a:pPr>
-            <a:r>
-              <a:rPr sz="1200">
+            <a:r>
+              <a:rPr sz="1400">
                 <a:latin typeface="Consolas"/>
               </a:rPr>
               <a:t>                return TariffOrderResult.failed("Validation failed");</a:t>
             </a:r>
           </a:p>
           <a:p>
-            <a:pPr>
-              <a:lnSpc>
-                <a:spcPct val="100000"/>
-              </a:lnSpc>
-              <a:spcBef>
-                <a:spcPts val="0"/>
-              </a:spcBef>
-              <a:spcAft>
-                <a:spcPts val="0"/>
-              </a:spcAft>
-            </a:pPr>
-            <a:r>
-              <a:rPr sz="1200">
+            <a:r>
+              <a:rPr sz="1400">
                 <a:latin typeface="Consolas"/>
               </a:rPr>
               <a:t>            }</a:t>
             </a:r>
           </a:p>
           <a:p>
-            <a:pPr>
-              <a:lnSpc>
-                <a:spcPct val="100000"/>
-              </a:lnSpc>
-              <a:spcBef>
-                <a:spcPts val="0"/>
-              </a:spcBef>
-              <a:spcAft>
-                <a:spcPts val="0"/>
-              </a:spcAft>
-            </a:pPr>
-            <a:r>
-              <a:rPr sz="1200">
+            <a:r>
+              <a:rPr sz="1400">
                 <a:latin typeface="Consolas"/>
               </a:rPr>
               <a:t>            return executeOrderProcess(request); // Details versteckt</a:t>
             </a:r>
           </a:p>
           <a:p>
-            <a:pPr>
-              <a:lnSpc>
-                <a:spcPct val="100000"/>
-              </a:lnSpc>
-              <a:spcBef>
-                <a:spcPts val="0"/>
-              </a:spcBef>
-              <a:spcAft>
-                <a:spcPts val="0"/>
-              </a:spcAft>
-            </a:pPr>
-            <a:r>
-              <a:rPr sz="1200">
+            <a:r>
+              <a:rPr sz="1400">
                 <a:latin typeface="Consolas"/>
               </a:rPr>
               <a:t>        } catch (Exception e) {</a:t>
             </a:r>
           </a:p>
           <a:p>
-            <a:pPr>
-              <a:lnSpc>
-                <a:spcPct val="100000"/>
-              </a:lnSpc>
-              <a:spcBef>
-                <a:spcPts val="0"/>
-              </a:spcBef>
-              <a:spcAft>
-                <a:spcPts val="0"/>
-              </a:spcAft>
-            </a:pPr>
-            <a:r>
-              <a:rPr sz="1200">
+            <a:r>
+              <a:rPr sz="1400">
                 <a:latin typeface="Consolas"/>
               </a:rPr>
               <a:t>            return TariffOrderResult.failed(e.getMessage());</a:t>
             </a:r>
           </a:p>
           <a:p>
-            <a:pPr>
-              <a:lnSpc>
-                <a:spcPct val="100000"/>
-              </a:lnSpc>
-              <a:spcBef>
-                <a:spcPts val="0"/>
-              </a:spcBef>
-              <a:spcAft>
-                <a:spcPts val="0"/>
-              </a:spcAft>
-            </a:pPr>
-            <a:r>
-              <a:rPr sz="1200">
+            <a:r>
+              <a:rPr sz="1400">
                 <a:latin typeface="Consolas"/>
               </a:rPr>
               <a:t>        }</a:t>
             </a:r>
           </a:p>
           <a:p>
-            <a:pPr>
-              <a:lnSpc>
-                <a:spcPct val="100000"/>
-              </a:lnSpc>
-              <a:spcBef>
-                <a:spcPts val="0"/>
-              </a:spcBef>
-              <a:spcAft>
-                <a:spcPts val="0"/>
-              </a:spcAft>
-            </a:pPr>
-            <a:r>
-              <a:rPr sz="1200">
+            <a:r>
+              <a:rPr sz="1400">
                 <a:latin typeface="Consolas"/>
               </a:rPr>
               <a:t>    }</a:t>
             </a:r>
           </a:p>
           <a:p>
-            <a:pPr>
-              <a:lnSpc>
-                <a:spcPct val="100000"/>
-              </a:lnSpc>
-              <a:spcBef>
-                <a:spcPts val="0"/>
-              </a:spcBef>
-              <a:spcAft>
-                <a:spcPts val="0"/>
-              </a:spcAft>
-            </a:pPr>
-            <a:r>
-              <a:rPr sz="1200">
+            <a:r>
+              <a:rPr sz="1400">
                 <a:latin typeface="Consolas"/>
               </a:rPr>
               <a:t>    // Parallele Validierungen für Performance</a:t>
             </a:r>
           </a:p>
           <a:p>
-            <a:pPr>
-              <a:lnSpc>
-                <a:spcPct val="100000"/>
-              </a:lnSpc>
-              <a:spcBef>
-                <a:spcPts val="0"/>
-              </a:spcBef>
-              <a:spcAft>
-                <a:spcPts val="0"/>
-              </a:spcAft>
-            </a:pPr>
-            <a:r>
-              <a:rPr sz="1200">
-                <a:latin typeface="Consolas"/>
-              </a:rPr>
-              <a:t>    private CompletableFuture&lt;ValidationResult&gt; validateOrderAsync(request) {</a:t>
-            </a:r>
-          </a:p>
-          <a:p>
-            <a:pPr>
-              <a:lnSpc>
-                <a:spcPct val="100000"/>
-              </a:lnSpc>
-              <a:spcBef>
-                <a:spcPts val="0"/>
-              </a:spcBef>
-              <a:spcAft>
-                <a:spcPts val="0"/>
-              </a:spcAft>
-            </a:pPr>
-            <a:r>
-              <a:rPr sz="1200">
+            <a:r>
+              <a:rPr sz="1400">
+                <a:latin typeface="Consolas"/>
+              </a:rPr>
+              <a:t>    private CompletableFuture validateOrderAsync(request) {</a:t>
+            </a:r>
+          </a:p>
+          <a:p>
+            <a:r>
+              <a:rPr sz="1400">
                 <a:latin typeface="Consolas"/>
               </a:rPr>
               <a:t>        // Unabhängige Service-Calls parallel ausführen</a:t>
             </a:r>
           </a:p>
           <a:p>
-            <a:pPr>
-              <a:lnSpc>
-                <a:spcPct val="100000"/>
-              </a:lnSpc>
-              <a:spcBef>
-                <a:spcPts val="0"/>
-              </a:spcBef>
-              <a:spcAft>
-                <a:spcPts val="0"/>
-              </a:spcAft>
-            </a:pPr>
-            <a:r>
-              <a:rPr sz="1200">
+            <a:r>
+              <a:rPr sz="1400">
                 <a:latin typeface="Consolas"/>
               </a:rPr>
               <a:t>    }</a:t>
             </a:r>
           </a:p>
           <a:p>
-            <a:pPr>
-              <a:lnSpc>
-                <a:spcPct val="100000"/>
-              </a:lnSpc>
-              <a:spcBef>
-                <a:spcPts val="0"/>
-              </a:spcBef>
-              <a:spcAft>
-                <a:spcPts val="0"/>
-              </a:spcAft>
-            </a:pPr>
-            <a:r>
-              <a:rPr sz="1200">
+            <a:r>
+              <a:rPr sz="1400">
                 <a:latin typeface="Consolas"/>
               </a:rPr>
               <a:t>}</a:t>
@@ -6938,7 +6900,7 @@
             <a:spLocks noGrp="1"/>
           </p:cNvSpPr>
           <p:nvPr>
-            <p:ph type="ctrTitle"/>
+            <p:ph type="title"/>
           </p:nvPr>
         </p:nvSpPr>
         <p:spPr/>
@@ -6947,9 +6909,6 @@
           <a:lstStyle/>
           <a:p>
             <a:r>
-              <a:rPr sz="3600" b="1">
-                <a:latin typeface="Calibri"/>
-              </a:rPr>
               <a:t>Proxy Pattern</a:t>
             </a:r>
           </a:p>
@@ -6957,19 +6916,114 @@
       </p:sp>
       <p:sp>
         <p:nvSpPr>
-          <p:cNvPr id="3" name="Subtitle 2"/>
-          <p:cNvSpPr>
-            <a:spLocks noGrp="1"/>
-          </p:cNvSpPr>
-          <p:nvPr>
-            <p:ph type="subTitle" idx="1"/>
+          <p:cNvPr id="3" name="Content Placeholder 2"/>
+          <p:cNvSpPr>
+            <a:spLocks noGrp="1"/>
+          </p:cNvSpPr>
+          <p:nvPr>
+            <p:ph idx="1"/>
           </p:nvPr>
         </p:nvSpPr>
         <p:spPr/>
         <p:txBody>
           <a:bodyPr/>
           <a:lstStyle/>
-          <a:p/>
+          <a:p>
+            <a:r>
+              <a:rPr sz="1400">
+                <a:latin typeface="Consolas"/>
+              </a:rPr>
+              <a:t>// Synchrone, ungecachte DB-Zugriffe</a:t>
+            </a:r>
+          </a:p>
+          <a:p>
+            <a:r>
+              <a:rPr sz="1400">
+                <a:latin typeface="Consolas"/>
+              </a:rPr>
+              <a:t>public class CustomerService {</a:t>
+            </a:r>
+          </a:p>
+          <a:p>
+            <a:r>
+              <a:rPr sz="1400">
+                <a:latin typeface="Consolas"/>
+              </a:rPr>
+              <a:t>    public CustomerData getCustomer(String id) {</a:t>
+            </a:r>
+          </a:p>
+          <a:p>
+            <a:r>
+              <a:rPr sz="1400">
+                <a:latin typeface="Consolas"/>
+              </a:rPr>
+              <a:t>        // Legacy-DB: 200ms+ pro Query!</a:t>
+            </a:r>
+          </a:p>
+          <a:p>
+            <a:r>
+              <a:rPr sz="1400">
+                <a:latin typeface="Consolas"/>
+              </a:rPr>
+              <a:t>        return legacyDatabase.findById(id);</a:t>
+            </a:r>
+          </a:p>
+          <a:p>
+            <a:r>
+              <a:rPr sz="1400">
+                <a:latin typeface="Consolas"/>
+              </a:rPr>
+              <a:t>    }</a:t>
+            </a:r>
+          </a:p>
+          <a:p>
+            <a:r>
+              <a:rPr sz="1400">
+                <a:latin typeface="Consolas"/>
+              </a:rPr>
+              <a:t>}</a:t>
+            </a:r>
+          </a:p>
+          <a:p>
+            <a:r>
+              <a:rPr sz="1400">
+                <a:latin typeface="Consolas"/>
+              </a:rPr>
+              <a:t>// Bei 1000 Requests/sec:</a:t>
+            </a:r>
+          </a:p>
+          <a:p>
+            <a:r>
+              <a:rPr sz="1400">
+                <a:latin typeface="Consolas"/>
+              </a:rPr>
+              <a:t>// 1000 × 200ms = 200 Sekunden DB-Zeit pro Sekunde</a:t>
+            </a:r>
+          </a:p>
+          <a:p>
+            <a:r>
+              <a:rPr sz="1400">
+                <a:latin typeface="Consolas"/>
+              </a:rPr>
+              <a:t>// System bricht zusammen!</a:t>
+            </a:r>
+          </a:p>
+          <a:p>
+            <a:r>
+              <a:rPr sz="1400">
+                <a:latin typeface="Consolas"/>
+              </a:rPr>
+              <a:t>// Memory-Verschwendung: Jeder Customer 2KB</a:t>
+            </a:r>
+          </a:p>
+          <a:p>
+            <a:r>
+              <a:rPr sz="1400">
+                <a:latin typeface="Consolas"/>
+              </a:rPr>
+              <a:t>// 50 Million Kunden × 2KB = 100GB RAM nur für Basis-Kundendaten</a:t>
+            </a:r>
+          </a:p>
         </p:txBody>
       </p:sp>
     </p:spTree>
@@ -7006,10 +7060,7 @@
           <a:lstStyle/>
           <a:p>
             <a:r>
-              <a:rPr sz="2800" b="1">
-                <a:latin typeface="Calibri"/>
-              </a:rPr>
-              <a:t>Code Smells identifiziert</a:t>
+              <a:t>Slide 14: Code Smells identifiziert</a:t>
             </a:r>
           </a:p>
         </p:txBody>
@@ -7029,66 +7080,38 @@
           <a:bodyPr/>
           <a:lstStyle/>
           <a:p>
-            <a:pPr/>
-            <a:r>
-              <a:rPr sz="1600">
-                <a:latin typeface="Calibri"/>
-              </a:rPr>
-              <a:t>**Latenz-Explosion**: 200ms+ Response-Zeit pro DB-Query</a:t>
-            </a:r>
-          </a:p>
-          <a:p>
-            <a:pPr/>
-            <a:r>
-              <a:rPr sz="1600">
-                <a:latin typeface="Calibri"/>
-              </a:rPr>
-              <a:t>**Memory-Verschwendung**: Redundante Daten millionenfach geladen</a:t>
-            </a:r>
-          </a:p>
-          <a:p>
-            <a:pPr/>
-            <a:r>
-              <a:rPr sz="1600">
-                <a:latin typeface="Calibri"/>
-              </a:rPr>
-              <a:t>**Cascade-Failure-Risk**: Langsame Services blockieren nachgelagerte Systeme</a:t>
-            </a:r>
-          </a:p>
-          <a:p>
-            <a:pPr/>
-            <a:r>
-              <a:rPr sz="1600">
-                <a:latin typeface="Calibri"/>
-              </a:rPr>
-              <a:t>**No Caching Strategy**: Identische Queries werden wiederholt ausgeführt</a:t>
-            </a:r>
-          </a:p>
-          <a:p>
-            <a:pPr/>
-            <a:r>
-              <a:rPr sz="1600">
-                <a:latin typeface="Calibri"/>
-              </a:rPr>
-              <a:t>**Synchronous Blocking**: Alle Threads warten auf DB-Response</a:t>
-            </a:r>
-          </a:p>
-          <a:p>
-            <a:pPr/>
-            <a:r>
-              <a:rPr sz="1600">
-                <a:latin typeface="Calibri"/>
-              </a:rPr>
-              <a:t>**Resource Exhaustion**: Connection Pools werden erschöpft</a:t>
-            </a:r>
-          </a:p>
-          <a:p>
-            <a:pPr/>
-            <a:r>
-              <a:rPr sz="1600">
-                <a:latin typeface="Calibri"/>
-              </a:rPr>
-              <a:t>**Poor User Experience**: Web-Interfaces werden unbenutzbar</a:t>
+            <a:r>
+              <a:t>Latenz-Explosion**: 200ms+ Response-Zeit pro DB-Query</a:t>
+            </a:r>
+          </a:p>
+          <a:p>
+            <a:r>
+              <a:t>Memory-Verschwendung**: Redundante Daten millionenfach geladen</a:t>
+            </a:r>
+          </a:p>
+          <a:p>
+            <a:r>
+              <a:t>Cascade-Failure-Risk**: Langsame Services blockieren nachgelagerte Systeme</a:t>
+            </a:r>
+          </a:p>
+          <a:p>
+            <a:r>
+              <a:t>No Caching Strategy**: Identische Queries werden wiederholt ausgeführt</a:t>
+            </a:r>
+          </a:p>
+          <a:p>
+            <a:r>
+              <a:t>Synchronous Blocking**: Alle Threads warten auf DB-Response</a:t>
+            </a:r>
+          </a:p>
+          <a:p>
+            <a:r>
+              <a:t>Resource Exhaustion**: Connection Pools werden erschöpft</a:t>
+            </a:r>
+          </a:p>
+          <a:p>
+            <a:r>
+              <a:t>Poor User Experience**: Web-Interfaces werden unbenutzbar</a:t>
             </a:r>
           </a:p>
         </p:txBody>
@@ -7127,10 +7150,7 @@
           <a:lstStyle/>
           <a:p>
             <a:r>
-              <a:rPr sz="2800" b="1">
-                <a:latin typeface="Calibri"/>
-              </a:rPr>
-              <a:t>Lösung: Proxy Pattern</a:t>
+              <a:t>Slide 15: Lösung: Proxy Pattern</a:t>
             </a:r>
           </a:p>
         </p:txBody>
@@ -7150,66 +7170,38 @@
           <a:bodyPr/>
           <a:lstStyle/>
           <a:p>
-            <a:pPr/>
-            <a:r>
-              <a:rPr sz="1600">
-                <a:latin typeface="Calibri"/>
-              </a:rPr>
-              <a:t>**Intelligente Zugriffssteuerung**: Proxy kontrolliert Zugriff auf teure Objekte</a:t>
-            </a:r>
-          </a:p>
-          <a:p>
-            <a:pPr/>
-            <a:r>
-              <a:rPr sz="1600">
-                <a:latin typeface="Calibri"/>
-              </a:rPr>
-              <a:t>**Transparente Optimierung**: Client merkt nichts von Performance-Verbesserungen</a:t>
-            </a:r>
-          </a:p>
-          <a:p>
-            <a:pPr/>
-            <a:r>
-              <a:rPr sz="1600">
-                <a:latin typeface="Calibri"/>
-              </a:rPr>
-              <a:t>**Lazy Loading**: Objekte nur bei tatsächlichem Bedarf laden</a:t>
-            </a:r>
-          </a:p>
-          <a:p>
-            <a:pPr/>
-            <a:r>
-              <a:rPr sz="1600">
-                <a:latin typeface="Calibri"/>
-              </a:rPr>
-              <a:t>**Caching-Integration**: Intelligente Zwischenspeicherung mit konfigurierbaren Policies</a:t>
-            </a:r>
-          </a:p>
-          <a:p>
-            <a:pPr/>
-            <a:r>
-              <a:rPr sz="1600">
-                <a:latin typeface="Calibri"/>
-              </a:rPr>
-              <a:t>**Security-Layer**: Transparent implementierte Sicherheitsprüfungen</a:t>
-            </a:r>
-          </a:p>
-          <a:p>
-            <a:pPr/>
-            <a:r>
-              <a:rPr sz="1600">
-                <a:latin typeface="Calibri"/>
-              </a:rPr>
-              <a:t>**Remote Proxy**: Netzwerk-Komplexität verstecken mit Resilience Patterns</a:t>
-            </a:r>
-          </a:p>
-          <a:p>
-            <a:pPr/>
-            <a:r>
-              <a:rPr sz="1600">
-                <a:latin typeface="Calibri"/>
-              </a:rPr>
-              <a:t>**Monitoring-Integration**: Zentrale Metriken für alle Service-Calls</a:t>
+            <a:r>
+              <a:t>Intelligente Zugriffssteuerung**: Proxy kontrolliert Zugriff auf teure Objekte</a:t>
+            </a:r>
+          </a:p>
+          <a:p>
+            <a:r>
+              <a:t>Transparente Optimierung**: Client merkt nichts von Performance-Verbesserungen</a:t>
+            </a:r>
+          </a:p>
+          <a:p>
+            <a:r>
+              <a:t>Lazy Loading**: Objekte nur bei tatsächlichem Bedarf laden</a:t>
+            </a:r>
+          </a:p>
+          <a:p>
+            <a:r>
+              <a:t>Caching-Integration**: Intelligente Zwischenspeicherung mit konfigurierbaren Policies</a:t>
+            </a:r>
+          </a:p>
+          <a:p>
+            <a:r>
+              <a:t>Security-Layer**: Transparent implementierte Sicherheitsprüfungen</a:t>
+            </a:r>
+          </a:p>
+          <a:p>
+            <a:r>
+              <a:t>Remote Proxy**: Netzwerk-Komplexität verstecken mit Resilience Patterns</a:t>
+            </a:r>
+          </a:p>
+          <a:p>
+            <a:r>
+              <a:t>Monitoring-Integration**: Zentrale Metriken für alle Service-Calls</a:t>
             </a:r>
           </a:p>
         </p:txBody>
@@ -7248,10 +7240,7 @@
           <a:lstStyle/>
           <a:p>
             <a:r>
-              <a:rPr sz="2800" b="1">
-                <a:latin typeface="Calibri"/>
-              </a:rPr>
-              <a:t>Implementierung</a:t>
+              <a:t>Slide 16: Implementierung</a:t>
             </a:r>
           </a:p>
         </p:txBody>
@@ -7268,364 +7257,155 @@
         </p:nvSpPr>
         <p:spPr/>
         <p:txBody>
-          <a:bodyPr tIns="91440" bIns="91440"/>
+          <a:bodyPr/>
           <a:lstStyle/>
           <a:p>
-            <a:pPr>
-              <a:lnSpc>
-                <a:spcPct val="100000"/>
-              </a:lnSpc>
-              <a:spcBef>
-                <a:spcPts val="0"/>
-              </a:spcBef>
-              <a:spcAft>
-                <a:spcPts val="0"/>
-              </a:spcAft>
-            </a:pPr>
-            <a:r>
-              <a:rPr sz="1200">
+            <a:r>
+              <a:rPr sz="1400">
                 <a:latin typeface="Consolas"/>
               </a:rPr>
               <a:t>// Virtual Proxy für Lazy Loading</a:t>
             </a:r>
           </a:p>
           <a:p>
-            <a:pPr>
-              <a:lnSpc>
-                <a:spcPct val="100000"/>
-              </a:lnSpc>
-              <a:spcBef>
-                <a:spcPts val="0"/>
-              </a:spcBef>
-              <a:spcAft>
-                <a:spcPts val="0"/>
-              </a:spcAft>
-            </a:pPr>
-            <a:r>
-              <a:rPr sz="1200">
+            <a:r>
+              <a:rPr sz="1400">
                 <a:latin typeface="Consolas"/>
               </a:rPr>
               <a:t>public class LazyCustomerServiceProxy implements CustomerService {</a:t>
             </a:r>
           </a:p>
           <a:p>
-            <a:pPr>
-              <a:lnSpc>
-                <a:spcPct val="100000"/>
-              </a:lnSpc>
-              <a:spcBef>
-                <a:spcPts val="0"/>
-              </a:spcBef>
-              <a:spcAft>
-                <a:spcPts val="0"/>
-              </a:spcAft>
-            </a:pPr>
-            <a:r>
-              <a:rPr sz="1200">
+            <a:r>
+              <a:rPr sz="1400">
                 <a:latin typeface="Consolas"/>
               </a:rPr>
               <a:t>    private final CustomerService realService;</a:t>
             </a:r>
           </a:p>
           <a:p>
-            <a:pPr>
-              <a:lnSpc>
-                <a:spcPct val="100000"/>
-              </a:lnSpc>
-              <a:spcBef>
-                <a:spcPts val="0"/>
-              </a:spcBef>
-              <a:spcAft>
-                <a:spcPts val="0"/>
-              </a:spcAft>
-            </a:pPr>
-            <a:r>
-              <a:rPr sz="1200">
-                <a:latin typeface="Consolas"/>
-              </a:rPr>
-              <a:t>    private final Map&lt;String, CustomerData&gt; loadedCustomers = new HashMap&lt;&gt;();</a:t>
-            </a:r>
-          </a:p>
-          <a:p>
-            <a:pPr>
-              <a:lnSpc>
-                <a:spcPct val="100000"/>
-              </a:lnSpc>
-              <a:spcBef>
-                <a:spcPts val="0"/>
-              </a:spcBef>
-              <a:spcAft>
-                <a:spcPts val="0"/>
-              </a:spcAft>
-            </a:pPr>
-            <a:r>
-              <a:rPr sz="1200">
+            <a:r>
+              <a:rPr sz="1400">
+                <a:latin typeface="Consolas"/>
+              </a:rPr>
+              <a:t>    private final Map loadedCustomers = new HashMap&lt;&gt;();</a:t>
+            </a:r>
+          </a:p>
+          <a:p>
+            <a:r>
+              <a:rPr sz="1400">
                 <a:latin typeface="Consolas"/>
               </a:rPr>
               <a:t>    public CustomerData getCustomer(String customerId) {</a:t>
             </a:r>
           </a:p>
           <a:p>
-            <a:pPr>
-              <a:lnSpc>
-                <a:spcPct val="100000"/>
-              </a:lnSpc>
-              <a:spcBef>
-                <a:spcPts val="0"/>
-              </a:spcBef>
-              <a:spcAft>
-                <a:spcPts val="0"/>
-              </a:spcAft>
-            </a:pPr>
-            <a:r>
-              <a:rPr sz="1200">
+            <a:r>
+              <a:rPr sz="1400">
                 <a:latin typeface="Consolas"/>
               </a:rPr>
               <a:t>        return loadedCustomers.computeIfAbsent(customerId, </a:t>
             </a:r>
           </a:p>
           <a:p>
-            <a:pPr>
-              <a:lnSpc>
-                <a:spcPct val="100000"/>
-              </a:lnSpc>
-              <a:spcBef>
-                <a:spcPts val="0"/>
-              </a:spcBef>
-              <a:spcAft>
-                <a:spcPts val="0"/>
-              </a:spcAft>
-            </a:pPr>
-            <a:r>
-              <a:rPr sz="1200">
+            <a:r>
+              <a:rPr sz="1400">
                 <a:latin typeface="Consolas"/>
               </a:rPr>
               <a:t>            id -&gt; realService.getCustomer(id)); // Lazy Loading</a:t>
             </a:r>
           </a:p>
           <a:p>
-            <a:pPr>
-              <a:lnSpc>
-                <a:spcPct val="100000"/>
-              </a:lnSpc>
-              <a:spcBef>
-                <a:spcPts val="0"/>
-              </a:spcBef>
-              <a:spcAft>
-                <a:spcPts val="0"/>
-              </a:spcAft>
-            </a:pPr>
-            <a:r>
-              <a:rPr sz="1200">
+            <a:r>
+              <a:rPr sz="1400">
                 <a:latin typeface="Consolas"/>
               </a:rPr>
               <a:t>    }</a:t>
             </a:r>
           </a:p>
           <a:p>
-            <a:pPr>
-              <a:lnSpc>
-                <a:spcPct val="100000"/>
-              </a:lnSpc>
-              <a:spcBef>
-                <a:spcPts val="0"/>
-              </a:spcBef>
-              <a:spcAft>
-                <a:spcPts val="0"/>
-              </a:spcAft>
-            </a:pPr>
-            <a:r>
-              <a:rPr sz="1200">
+            <a:r>
+              <a:rPr sz="1400">
                 <a:latin typeface="Consolas"/>
               </a:rPr>
               <a:t>}</a:t>
             </a:r>
           </a:p>
           <a:p>
-            <a:pPr>
-              <a:lnSpc>
-                <a:spcPct val="100000"/>
-              </a:lnSpc>
-              <a:spcBef>
-                <a:spcPts val="0"/>
-              </a:spcBef>
-              <a:spcAft>
-                <a:spcPts val="0"/>
-              </a:spcAft>
-            </a:pPr>
-            <a:r>
-              <a:rPr sz="1200">
+            <a:r>
+              <a:rPr sz="1400">
                 <a:latin typeface="Consolas"/>
               </a:rPr>
               <a:t>// Caching Proxy für Performance</a:t>
             </a:r>
           </a:p>
           <a:p>
-            <a:pPr>
-              <a:lnSpc>
-                <a:spcPct val="100000"/>
-              </a:lnSpc>
-              <a:spcBef>
-                <a:spcPts val="0"/>
-              </a:spcBef>
-              <a:spcAft>
-                <a:spcPts val="0"/>
-              </a:spcAft>
-            </a:pPr>
-            <a:r>
-              <a:rPr sz="1200">
+            <a:r>
+              <a:rPr sz="1400">
                 <a:latin typeface="Consolas"/>
               </a:rPr>
               <a:t>@Component</a:t>
             </a:r>
           </a:p>
           <a:p>
-            <a:pPr>
-              <a:lnSpc>
-                <a:spcPct val="100000"/>
-              </a:lnSpc>
-              <a:spcBef>
-                <a:spcPts val="0"/>
-              </a:spcBef>
-              <a:spcAft>
-                <a:spcPts val="0"/>
-              </a:spcAft>
-            </a:pPr>
-            <a:r>
-              <a:rPr sz="1200">
+            <a:r>
+              <a:rPr sz="1400">
                 <a:latin typeface="Consolas"/>
               </a:rPr>
               <a:t>public class CachedCustomerServiceProxy implements CustomerService {</a:t>
             </a:r>
           </a:p>
           <a:p>
-            <a:pPr>
-              <a:lnSpc>
-                <a:spcPct val="100000"/>
-              </a:lnSpc>
-              <a:spcBef>
-                <a:spcPts val="0"/>
-              </a:spcBef>
-              <a:spcAft>
-                <a:spcPts val="0"/>
-              </a:spcAft>
-            </a:pPr>
-            <a:r>
-              <a:rPr sz="1200">
-                <a:latin typeface="Consolas"/>
-              </a:rPr>
-              <a:t>    private final Cache&lt;String, CustomerData&gt; customerCache;</a:t>
-            </a:r>
-          </a:p>
-          <a:p>
-            <a:pPr>
-              <a:lnSpc>
-                <a:spcPct val="100000"/>
-              </a:lnSpc>
-              <a:spcBef>
-                <a:spcPts val="0"/>
-              </a:spcBef>
-              <a:spcAft>
-                <a:spcPts val="0"/>
-              </a:spcAft>
-            </a:pPr>
-            <a:r>
-              <a:rPr sz="1200">
+            <a:r>
+              <a:rPr sz="1400">
+                <a:latin typeface="Consolas"/>
+              </a:rPr>
+              <a:t>    private final Cache customerCache;</a:t>
+            </a:r>
+          </a:p>
+          <a:p>
+            <a:r>
+              <a:rPr sz="1400">
                 <a:latin typeface="Consolas"/>
               </a:rPr>
               <a:t>    public CustomerData getCustomer(String customerId) {</a:t>
             </a:r>
           </a:p>
           <a:p>
-            <a:pPr>
-              <a:lnSpc>
-                <a:spcPct val="100000"/>
-              </a:lnSpc>
-              <a:spcBef>
-                <a:spcPts val="0"/>
-              </a:spcBef>
-              <a:spcAft>
-                <a:spcPts val="0"/>
-              </a:spcAft>
-            </a:pPr>
-            <a:r>
-              <a:rPr sz="1200">
+            <a:r>
+              <a:rPr sz="1400">
                 <a:latin typeface="Consolas"/>
               </a:rPr>
               <a:t>        return customerCache.get(customerId, id -&gt; {</a:t>
             </a:r>
           </a:p>
           <a:p>
-            <a:pPr>
-              <a:lnSpc>
-                <a:spcPct val="100000"/>
-              </a:lnSpc>
-              <a:spcBef>
-                <a:spcPts val="0"/>
-              </a:spcBef>
-              <a:spcAft>
-                <a:spcPts val="0"/>
-              </a:spcAft>
-            </a:pPr>
-            <a:r>
-              <a:rPr sz="1200">
+            <a:r>
+              <a:rPr sz="1400">
                 <a:latin typeface="Consolas"/>
               </a:rPr>
               <a:t>            return realService.getCustomer(id); // Cache Miss</a:t>
             </a:r>
           </a:p>
           <a:p>
-            <a:pPr>
-              <a:lnSpc>
-                <a:spcPct val="100000"/>
-              </a:lnSpc>
-              <a:spcBef>
-                <a:spcPts val="0"/>
-              </a:spcBef>
-              <a:spcAft>
-                <a:spcPts val="0"/>
-              </a:spcAft>
-            </a:pPr>
-            <a:r>
-              <a:rPr sz="1200">
+            <a:r>
+              <a:rPr sz="1400">
                 <a:latin typeface="Consolas"/>
               </a:rPr>
               <a:t>        });</a:t>
             </a:r>
           </a:p>
           <a:p>
-            <a:pPr>
-              <a:lnSpc>
-                <a:spcPct val="100000"/>
-              </a:lnSpc>
-              <a:spcBef>
-                <a:spcPts val="0"/>
-              </a:spcBef>
-              <a:spcAft>
-                <a:spcPts val="0"/>
-              </a:spcAft>
-            </a:pPr>
-            <a:r>
-              <a:rPr sz="1200">
+            <a:r>
+              <a:rPr sz="1400">
                 <a:latin typeface="Consolas"/>
               </a:rPr>
               <a:t>    }</a:t>
             </a:r>
           </a:p>
           <a:p>
-            <a:pPr>
-              <a:lnSpc>
-                <a:spcPct val="100000"/>
-              </a:lnSpc>
-              <a:spcBef>
-                <a:spcPts val="0"/>
-              </a:spcBef>
-              <a:spcAft>
-                <a:spcPts val="0"/>
-              </a:spcAft>
-            </a:pPr>
-            <a:r>
-              <a:rPr sz="1200">
+            <a:r>
+              <a:rPr sz="1400">
                 <a:latin typeface="Consolas"/>
               </a:rPr>
               <a:t>}</a:t>
@@ -7658,7 +7438,7 @@
             <a:spLocks noGrp="1"/>
           </p:cNvSpPr>
           <p:nvPr>
-            <p:ph type="ctrTitle"/>
+            <p:ph type="title"/>
           </p:nvPr>
         </p:nvSpPr>
         <p:spPr/>
@@ -7667,9 +7447,6 @@
           <a:lstStyle/>
           <a:p>
             <a:r>
-              <a:rPr sz="3600" b="1">
-                <a:latin typeface="Calibri"/>
-              </a:rPr>
               <a:t>Flyweight Pattern</a:t>
             </a:r>
           </a:p>
@@ -7677,19 +7454,106 @@
       </p:sp>
       <p:sp>
         <p:nvSpPr>
-          <p:cNvPr id="3" name="Subtitle 2"/>
-          <p:cNvSpPr>
-            <a:spLocks noGrp="1"/>
-          </p:cNvSpPr>
-          <p:nvPr>
-            <p:ph type="subTitle" idx="1"/>
+          <p:cNvPr id="3" name="Content Placeholder 2"/>
+          <p:cNvSpPr>
+            <a:spLocks noGrp="1"/>
+          </p:cNvSpPr>
+          <p:nvPr>
+            <p:ph idx="1"/>
           </p:nvPr>
         </p:nvSpPr>
         <p:spPr/>
         <p:txBody>
           <a:bodyPr/>
           <a:lstStyle/>
-          <a:p/>
+          <a:p>
+            <a:r>
+              <a:rPr sz="1400">
+                <a:latin typeface="Consolas"/>
+              </a:rPr>
+              <a:t>// REDUNDANT: Gleiche Tarif-Daten millionenfach dupliziert</a:t>
+            </a:r>
+          </a:p>
+          <a:p>
+            <a:r>
+              <a:rPr sz="1400">
+                <a:latin typeface="Consolas"/>
+              </a:rPr>
+              <a:t>public class CustomerData {</a:t>
+            </a:r>
+          </a:p>
+          <a:p>
+            <a:r>
+              <a:rPr sz="1400">
+                <a:latin typeface="Consolas"/>
+              </a:rPr>
+              <a:t>    private String customerId;          // INDIVIDUELL</a:t>
+            </a:r>
+          </a:p>
+          <a:p>
+            <a:r>
+              <a:rPr sz="1400">
+                <a:latin typeface="Consolas"/>
+              </a:rPr>
+              <a:t>    private String name;                // INDIVIDUELL</a:t>
+            </a:r>
+          </a:p>
+          <a:p>
+            <a:r>
+              <a:rPr sz="1400">
+                <a:latin typeface="Consolas"/>
+              </a:rPr>
+              <a:t>    // Nur ~50 verschiedene Werte für Millionen Kunden!</a:t>
+            </a:r>
+          </a:p>
+          <a:p>
+            <a:r>
+              <a:rPr sz="1400">
+                <a:latin typeface="Consolas"/>
+              </a:rPr>
+              <a:t>    private String tariffPlanName;      // "MagentaMobil L" - 1M× dupliziert!</a:t>
+            </a:r>
+          </a:p>
+          <a:p>
+            <a:r>
+              <a:rPr sz="1400">
+                <a:latin typeface="Consolas"/>
+              </a:rPr>
+              <a:t>    private String tariffDescription;   // Beschreibung - 1M× dupliziert!</a:t>
+            </a:r>
+          </a:p>
+          <a:p>
+            <a:r>
+              <a:rPr sz="1400">
+                <a:latin typeface="Consolas"/>
+              </a:rPr>
+              <a:t>    private BigDecimal tariffPrice;     // 49.99 - 1M× dupliziert!</a:t>
+            </a:r>
+          </a:p>
+          <a:p>
+            <a:r>
+              <a:rPr sz="1400">
+                <a:latin typeface="Consolas"/>
+              </a:rPr>
+              <a:t>    private Set tariffFeatures; // Feature-Liste - 1M× dupliziert!</a:t>
+            </a:r>
+          </a:p>
+          <a:p>
+            <a:r>
+              <a:rPr sz="1400">
+                <a:latin typeface="Consolas"/>
+              </a:rPr>
+              <a:t>}</a:t>
+            </a:r>
+          </a:p>
+          <a:p>
+            <a:r>
+              <a:rPr sz="1400">
+                <a:latin typeface="Consolas"/>
+              </a:rPr>
+              <a:t>// Memory-Verschwendung: 500MB für identische Strings!</a:t>
+            </a:r>
+          </a:p>
         </p:txBody>
       </p:sp>
     </p:spTree>
@@ -7726,10 +7590,7 @@
           <a:lstStyle/>
           <a:p>
             <a:r>
-              <a:rPr sz="2800" b="1">
-                <a:latin typeface="Calibri"/>
-              </a:rPr>
-              <a:t>Code Smells identifiziert</a:t>
+              <a:t>Slide 18: Code Smells identifiziert</a:t>
             </a:r>
           </a:p>
         </p:txBody>
@@ -7749,66 +7610,38 @@
           <a:bodyPr/>
           <a:lstStyle/>
           <a:p>
-            <a:pPr/>
-            <a:r>
-              <a:rPr sz="1600">
-                <a:latin typeface="Calibri"/>
-              </a:rPr>
-              <a:t>**Memory-Explosion**: 50 verschiedene Tarife × 1M Kunden = 50M redundante Kopien</a:t>
-            </a:r>
-          </a:p>
-          <a:p>
-            <a:pPr/>
-            <a:r>
-              <a:rPr sz="1600">
-                <a:latin typeface="Calibri"/>
-              </a:rPr>
-              <a:t>**Gigabyte-Verschwendung**: Identische Strings millionenfach im Memory</a:t>
-            </a:r>
-          </a:p>
-          <a:p>
-            <a:pPr/>
-            <a:r>
-              <a:rPr sz="1600">
-                <a:latin typeface="Calibri"/>
-              </a:rPr>
-              <a:t>**Skalierungs-Problem**: Memory-Verbrauch explodiert mit Kundenzahl</a:t>
-            </a:r>
-          </a:p>
-          <a:p>
-            <a:pPr/>
-            <a:r>
-              <a:rPr sz="1600">
-                <a:latin typeface="Calibri"/>
-              </a:rPr>
-              <a:t>**Cloud-Kosten-Explosion**: Ineffiziente Memory-Nutzung = hohe Infrastruktur-Kosten</a:t>
-            </a:r>
-          </a:p>
-          <a:p>
-            <a:pPr/>
-            <a:r>
-              <a:rPr sz="1600">
-                <a:latin typeface="Calibri"/>
-              </a:rPr>
-              <a:t>**Cache-Ineffizienz**: Redundante Daten verdrängen wichtige Daten aus Caches</a:t>
-            </a:r>
-          </a:p>
-          <a:p>
-            <a:pPr/>
-            <a:r>
-              <a:rPr sz="1600">
-                <a:latin typeface="Calibri"/>
-              </a:rPr>
-              <a:t>**GC-Pressure**: Garbage Collector überlastet durch redundante Objekte</a:t>
-            </a:r>
-          </a:p>
-          <a:p>
-            <a:pPr/>
-            <a:r>
-              <a:rPr sz="1600">
-                <a:latin typeface="Calibri"/>
-              </a:rPr>
-              <a:t>**Network-Overhead**: Redundante Daten werden über Netzwerk übertragen</a:t>
+            <a:r>
+              <a:t>Memory-Explosion**: 50 verschiedene Tarife × 1M Kunden = 50M redundante Kopien</a:t>
+            </a:r>
+          </a:p>
+          <a:p>
+            <a:r>
+              <a:t>Gigabyte-Verschwendung**: Identische Strings millionenfach im Memory</a:t>
+            </a:r>
+          </a:p>
+          <a:p>
+            <a:r>
+              <a:t>Skalierungs-Problem**: Memory-Verbrauch explodiert mit Kundenzahl</a:t>
+            </a:r>
+          </a:p>
+          <a:p>
+            <a:r>
+              <a:t>Cloud-Kosten-Explosion**: Ineffiziente Memory-Nutzung = hohe Infrastruktur-Kosten</a:t>
+            </a:r>
+          </a:p>
+          <a:p>
+            <a:r>
+              <a:t>Cache-Ineffizienz**: Redundante Daten verdrängen wichtige Daten aus Caches</a:t>
+            </a:r>
+          </a:p>
+          <a:p>
+            <a:r>
+              <a:t>GC-Pressure**: Garbage Collector überlastet durch redundante Objekte</a:t>
+            </a:r>
+          </a:p>
+          <a:p>
+            <a:r>
+              <a:t>Network-Overhead**: Redundante Daten werden über Netzwerk übertragen</a:t>
             </a:r>
           </a:p>
         </p:txBody>
@@ -7838,7 +7671,7 @@
             <a:spLocks noGrp="1"/>
           </p:cNvSpPr>
           <p:nvPr>
-            <p:ph type="ctrTitle"/>
+            <p:ph type="title"/>
           </p:nvPr>
         </p:nvSpPr>
         <p:spPr/>
@@ -7847,9 +7680,6 @@
           <a:lstStyle/>
           <a:p>
             <a:r>
-              <a:rPr sz="3600" b="1">
-                <a:latin typeface="Calibri"/>
-              </a:rPr>
               <a:t>Decorator Pattern</a:t>
             </a:r>
           </a:p>
@@ -7857,19 +7687,98 @@
       </p:sp>
       <p:sp>
         <p:nvSpPr>
-          <p:cNvPr id="3" name="Subtitle 2"/>
-          <p:cNvSpPr>
-            <a:spLocks noGrp="1"/>
-          </p:cNvSpPr>
-          <p:nvPr>
-            <p:ph type="subTitle" idx="1"/>
+          <p:cNvPr id="3" name="Content Placeholder 2"/>
+          <p:cNvSpPr>
+            <a:spLocks noGrp="1"/>
+          </p:cNvSpPr>
+          <p:nvPr>
+            <p:ph idx="1"/>
           </p:nvPr>
         </p:nvSpPr>
         <p:spPr/>
         <p:txBody>
           <a:bodyPr/>
           <a:lstStyle/>
-          <a:p/>
+          <a:p>
+            <a:r>
+              <a:rPr sz="1400">
+                <a:latin typeface="Consolas"/>
+              </a:rPr>
+              <a:t>// Exponentielles Wachstum-Problem</a:t>
+            </a:r>
+          </a:p>
+          <a:p>
+            <a:r>
+              <a:rPr sz="1400">
+                <a:latin typeface="Consolas"/>
+              </a:rPr>
+              <a:t>BasicTariff</a:t>
+            </a:r>
+          </a:p>
+          <a:p>
+            <a:r>
+              <a:rPr sz="1400">
+                <a:latin typeface="Consolas"/>
+              </a:rPr>
+              <a:t>BasicTariffWithData</a:t>
+            </a:r>
+          </a:p>
+          <a:p>
+            <a:r>
+              <a:rPr sz="1400">
+                <a:latin typeface="Consolas"/>
+              </a:rPr>
+              <a:t>BasicTariffWithDataAndRoaming  </a:t>
+            </a:r>
+          </a:p>
+          <a:p>
+            <a:r>
+              <a:rPr sz="1400">
+                <a:latin typeface="Consolas"/>
+              </a:rPr>
+              <a:t>// Bei n Features = 2^n Klassen!</a:t>
+            </a:r>
+          </a:p>
+          <a:p>
+            <a:r>
+              <a:rPr sz="1400">
+                <a:latin typeface="Consolas"/>
+              </a:rPr>
+              <a:t>// Vererbungs-Explosion</a:t>
+            </a:r>
+          </a:p>
+          <a:p>
+            <a:r>
+              <a:rPr sz="1400">
+                <a:latin typeface="Consolas"/>
+              </a:rPr>
+              <a:t>public class BasicTariffWithDataAndRoamingAndHotspot </a:t>
+            </a:r>
+          </a:p>
+          <a:p>
+            <a:r>
+              <a:rPr sz="1400">
+                <a:latin typeface="Consolas"/>
+              </a:rPr>
+              <a:t>    extends BasicTariffWithDataAndRoaming {</a:t>
+            </a:r>
+          </a:p>
+          <a:p>
+            <a:r>
+              <a:rPr sz="1400">
+                <a:latin typeface="Consolas"/>
+              </a:rPr>
+              <a:t>    // Bei nur 10 Tarif-Optionen entstehen 1.024 Klassen!</a:t>
+            </a:r>
+          </a:p>
+          <a:p>
+            <a:r>
+              <a:rPr sz="1400">
+                <a:latin typeface="Consolas"/>
+              </a:rPr>
+              <a:t>}</a:t>
+            </a:r>
+          </a:p>
         </p:txBody>
       </p:sp>
     </p:spTree>
@@ -7906,10 +7815,7 @@
           <a:lstStyle/>
           <a:p>
             <a:r>
-              <a:rPr sz="2800" b="1">
-                <a:latin typeface="Calibri"/>
-              </a:rPr>
-              <a:t>Lösung: Flyweight Pattern</a:t>
+              <a:t>Slide 19: Lösung: Flyweight Pattern</a:t>
             </a:r>
           </a:p>
         </p:txBody>
@@ -7929,66 +7835,38 @@
           <a:bodyPr/>
           <a:lstStyle/>
           <a:p>
-            <a:pPr/>
-            <a:r>
-              <a:rPr sz="1600">
-                <a:latin typeface="Calibri"/>
-              </a:rPr>
-              <a:t>**Intrinsic vs. Extrinsic State**: Geteilte von individuellen Daten trennen</a:t>
-            </a:r>
-          </a:p>
-          <a:p>
-            <a:pPr/>
-            <a:r>
-              <a:rPr sz="1600">
-                <a:latin typeface="Calibri"/>
-              </a:rPr>
-              <a:t>**Memory-Sharing**: Identische Objekte nur einmal im Memory speichern</a:t>
-            </a:r>
-          </a:p>
-          <a:p>
-            <a:pPr/>
-            <a:r>
-              <a:rPr sz="1600">
-                <a:latin typeface="Calibri"/>
-              </a:rPr>
-              <a:t>**Factory-Management**: Zentrale Verwaltung garantiert Singleton-Eigenschaften</a:t>
-            </a:r>
-          </a:p>
-          <a:p>
-            <a:pPr/>
-            <a:r>
-              <a:rPr sz="1600">
-                <a:latin typeface="Calibri"/>
-              </a:rPr>
-              <a:t>**Immutable Flyweights**: Thread-Safety durch Unveränderlichkeit</a:t>
-            </a:r>
-          </a:p>
-          <a:p>
-            <a:pPr/>
-            <a:r>
-              <a:rPr sz="1600">
-                <a:latin typeface="Calibri"/>
-              </a:rPr>
-              <a:t>**Context Pattern**: Individuelle Daten als Parameter-Objekte</a:t>
-            </a:r>
-          </a:p>
-          <a:p>
-            <a:pPr/>
-            <a:r>
-              <a:rPr sz="1600">
-                <a:latin typeface="Calibri"/>
-              </a:rPr>
-              <a:t>**70%+ Memory-Ersparnis**: Dramatische Reduktion des Speicherverbrauchs</a:t>
-            </a:r>
-          </a:p>
-          <a:p>
-            <a:pPr/>
-            <a:r>
-              <a:rPr sz="1600">
-                <a:latin typeface="Calibri"/>
-              </a:rPr>
-              <a:t>**Lineare Skalierung**: Memory-Verbrauch wächst linear mit Kundenzahl</a:t>
+            <a:r>
+              <a:t>Intrinsic vs. Extrinsic State**: Geteilte von individuellen Daten trennen</a:t>
+            </a:r>
+          </a:p>
+          <a:p>
+            <a:r>
+              <a:t>Memory-Sharing**: Identische Objekte nur einmal im Memory speichern</a:t>
+            </a:r>
+          </a:p>
+          <a:p>
+            <a:r>
+              <a:t>Factory-Management**: Zentrale Verwaltung garantiert Singleton-Eigenschaften</a:t>
+            </a:r>
+          </a:p>
+          <a:p>
+            <a:r>
+              <a:t>Immutable Flyweights**: Thread-Safety durch Unveränderlichkeit</a:t>
+            </a:r>
+          </a:p>
+          <a:p>
+            <a:r>
+              <a:t>Context Pattern**: Individuelle Daten als Parameter-Objekte</a:t>
+            </a:r>
+          </a:p>
+          <a:p>
+            <a:r>
+              <a:t>70%+ Memory-Ersparnis**: Dramatische Reduktion des Speicherverbrauchs</a:t>
+            </a:r>
+          </a:p>
+          <a:p>
+            <a:r>
+              <a:t>Lineare Skalierung**: Memory-Verbrauch wächst linear mit Kundenzahl</a:t>
             </a:r>
           </a:p>
         </p:txBody>
@@ -8027,10 +7905,7 @@
           <a:lstStyle/>
           <a:p>
             <a:r>
-              <a:rPr sz="2800" b="1">
-                <a:latin typeface="Calibri"/>
-              </a:rPr>
-              <a:t>Implementierung</a:t>
+              <a:t>Slide 20: Implementierung</a:t>
             </a:r>
           </a:p>
         </p:txBody>
@@ -8047,440 +7922,187 @@
         </p:nvSpPr>
         <p:spPr/>
         <p:txBody>
-          <a:bodyPr tIns="91440" bIns="91440"/>
+          <a:bodyPr/>
           <a:lstStyle/>
           <a:p>
-            <a:pPr>
-              <a:lnSpc>
-                <a:spcPct val="100000"/>
-              </a:lnSpc>
-              <a:spcBef>
-                <a:spcPts val="0"/>
-              </a:spcBef>
-              <a:spcAft>
-                <a:spcPts val="0"/>
-              </a:spcAft>
-            </a:pPr>
-            <a:r>
-              <a:rPr sz="1200">
+            <a:r>
+              <a:rPr sz="1400">
                 <a:latin typeface="Consolas"/>
               </a:rPr>
               <a:t>// Flyweight: Nur intrinsic (geteilte) Properties</a:t>
             </a:r>
           </a:p>
           <a:p>
-            <a:pPr>
-              <a:lnSpc>
-                <a:spcPct val="100000"/>
-              </a:lnSpc>
-              <a:spcBef>
-                <a:spcPts val="0"/>
-              </a:spcBef>
-              <a:spcAft>
-                <a:spcPts val="0"/>
-              </a:spcAft>
-            </a:pPr>
-            <a:r>
-              <a:rPr sz="1200">
+            <a:r>
+              <a:rPr sz="1400">
                 <a:latin typeface="Consolas"/>
               </a:rPr>
               <a:t>public class TariffPlanFlyweight {</a:t>
             </a:r>
           </a:p>
           <a:p>
-            <a:pPr>
-              <a:lnSpc>
-                <a:spcPct val="100000"/>
-              </a:lnSpc>
-              <a:spcBef>
-                <a:spcPts val="0"/>
-              </a:spcBef>
-              <a:spcAft>
-                <a:spcPts val="0"/>
-              </a:spcAft>
-            </a:pPr>
-            <a:r>
-              <a:rPr sz="1200">
+            <a:r>
+              <a:rPr sz="1400">
                 <a:latin typeface="Consolas"/>
               </a:rPr>
               <a:t>    private final String planName;          // Intrinsic - geteilt</a:t>
             </a:r>
           </a:p>
           <a:p>
-            <a:pPr>
-              <a:lnSpc>
-                <a:spcPct val="100000"/>
-              </a:lnSpc>
-              <a:spcBef>
-                <a:spcPts val="0"/>
-              </a:spcBef>
-              <a:spcAft>
-                <a:spcPts val="0"/>
-              </a:spcAft>
-            </a:pPr>
-            <a:r>
-              <a:rPr sz="1200">
+            <a:r>
+              <a:rPr sz="1400">
                 <a:latin typeface="Consolas"/>
               </a:rPr>
               <a:t>    private final String description;       // Intrinsic - geteilt  </a:t>
             </a:r>
           </a:p>
           <a:p>
-            <a:pPr>
-              <a:lnSpc>
-                <a:spcPct val="100000"/>
-              </a:lnSpc>
-              <a:spcBef>
-                <a:spcPts val="0"/>
-              </a:spcBef>
-              <a:spcAft>
-                <a:spcPts val="0"/>
-              </a:spcAft>
-            </a:pPr>
-            <a:r>
-              <a:rPr sz="1200">
+            <a:r>
+              <a:rPr sz="1400">
                 <a:latin typeface="Consolas"/>
               </a:rPr>
               <a:t>    private final BigDecimal basePrice;     // Intrinsic - geteilt</a:t>
             </a:r>
           </a:p>
           <a:p>
-            <a:pPr>
-              <a:lnSpc>
-                <a:spcPct val="100000"/>
-              </a:lnSpc>
-              <a:spcBef>
-                <a:spcPts val="0"/>
-              </a:spcBef>
-              <a:spcAft>
-                <a:spcPts val="0"/>
-              </a:spcAft>
-            </a:pPr>
-            <a:r>
-              <a:rPr sz="1200">
-                <a:latin typeface="Consolas"/>
-              </a:rPr>
-              <a:t>    private final Set&lt;String&gt; features;     // Intrinsic - geteilt</a:t>
-            </a:r>
-          </a:p>
-          <a:p>
-            <a:pPr>
-              <a:lnSpc>
-                <a:spcPct val="100000"/>
-              </a:lnSpc>
-              <a:spcBef>
-                <a:spcPts val="0"/>
-              </a:spcBef>
-              <a:spcAft>
-                <a:spcPts val="0"/>
-              </a:spcAft>
-            </a:pPr>
-            <a:r>
-              <a:rPr sz="1200">
+            <a:r>
+              <a:rPr sz="1400">
+                <a:latin typeface="Consolas"/>
+              </a:rPr>
+              <a:t>    private final Set features;     // Intrinsic - geteilt</a:t>
+            </a:r>
+          </a:p>
+          <a:p>
+            <a:r>
+              <a:rPr sz="1400">
                 <a:latin typeface="Consolas"/>
               </a:rPr>
               <a:t>    // Business-Operation mit extrinsic context</a:t>
             </a:r>
           </a:p>
           <a:p>
-            <a:pPr>
-              <a:lnSpc>
-                <a:spcPct val="100000"/>
-              </a:lnSpc>
-              <a:spcBef>
-                <a:spcPts val="0"/>
-              </a:spcBef>
-              <a:spcAft>
-                <a:spcPts val="0"/>
-              </a:spcAft>
-            </a:pPr>
-            <a:r>
-              <a:rPr sz="1200">
+            <a:r>
+              <a:rPr sz="1400">
                 <a:latin typeface="Consolas"/>
               </a:rPr>
               <a:t>    public CustomerBill calculateBill(CustomerContext context) {</a:t>
             </a:r>
           </a:p>
           <a:p>
-            <a:pPr>
-              <a:lnSpc>
-                <a:spcPct val="100000"/>
-              </a:lnSpc>
-              <a:spcBef>
-                <a:spcPts val="0"/>
-              </a:spcBef>
-              <a:spcAft>
-                <a:spcPts val="0"/>
-              </a:spcAft>
-            </a:pPr>
-            <a:r>
-              <a:rPr sz="1200">
+            <a:r>
+              <a:rPr sz="1400">
                 <a:latin typeface="Consolas"/>
               </a:rPr>
               <a:t>        BigDecimal finalPrice = basePrice;</a:t>
             </a:r>
           </a:p>
           <a:p>
-            <a:pPr>
-              <a:lnSpc>
-                <a:spcPct val="100000"/>
-              </a:lnSpc>
-              <a:spcBef>
-                <a:spcPts val="0"/>
-              </a:spcBef>
-              <a:spcAft>
-                <a:spcPts val="0"/>
-              </a:spcAft>
-            </a:pPr>
-            <a:r>
-              <a:rPr sz="1200">
+            <a:r>
+              <a:rPr sz="1400">
                 <a:latin typeface="Consolas"/>
               </a:rPr>
               <a:t>        if (context.hasLoyaltyDiscount()) {</a:t>
             </a:r>
           </a:p>
           <a:p>
-            <a:pPr>
-              <a:lnSpc>
-                <a:spcPct val="100000"/>
-              </a:lnSpc>
-              <a:spcBef>
-                <a:spcPts val="0"/>
-              </a:spcBef>
-              <a:spcAft>
-                <a:spcPts val="0"/>
-              </a:spcAft>
-            </a:pPr>
-            <a:r>
-              <a:rPr sz="1200">
+            <a:r>
+              <a:rPr sz="1400">
                 <a:latin typeface="Consolas"/>
               </a:rPr>
               <a:t>            finalPrice = finalPrice.multiply(BigDecimal.valueOf(0.9));</a:t>
             </a:r>
           </a:p>
           <a:p>
-            <a:pPr>
-              <a:lnSpc>
-                <a:spcPct val="100000"/>
-              </a:lnSpc>
-              <a:spcBef>
-                <a:spcPts val="0"/>
-              </a:spcBef>
-              <a:spcAft>
-                <a:spcPts val="0"/>
-              </a:spcAft>
-            </a:pPr>
-            <a:r>
-              <a:rPr sz="1200">
+            <a:r>
+              <a:rPr sz="1400">
                 <a:latin typeface="Consolas"/>
               </a:rPr>
               <a:t>        }</a:t>
             </a:r>
           </a:p>
           <a:p>
-            <a:pPr>
-              <a:lnSpc>
-                <a:spcPct val="100000"/>
-              </a:lnSpc>
-              <a:spcBef>
-                <a:spcPts val="0"/>
-              </a:spcBef>
-              <a:spcAft>
-                <a:spcPts val="0"/>
-              </a:spcAft>
-            </a:pPr>
-            <a:r>
-              <a:rPr sz="1200">
+            <a:r>
+              <a:rPr sz="1400">
                 <a:latin typeface="Consolas"/>
               </a:rPr>
               <a:t>        return new CustomerBill(context.getCustomerId(), planName, finalPrice);</a:t>
             </a:r>
           </a:p>
           <a:p>
-            <a:pPr>
-              <a:lnSpc>
-                <a:spcPct val="100000"/>
-              </a:lnSpc>
-              <a:spcBef>
-                <a:spcPts val="0"/>
-              </a:spcBef>
-              <a:spcAft>
-                <a:spcPts val="0"/>
-              </a:spcAft>
-            </a:pPr>
-            <a:r>
-              <a:rPr sz="1200">
+            <a:r>
+              <a:rPr sz="1400">
                 <a:latin typeface="Consolas"/>
               </a:rPr>
               <a:t>    }</a:t>
             </a:r>
           </a:p>
           <a:p>
-            <a:pPr>
-              <a:lnSpc>
-                <a:spcPct val="100000"/>
-              </a:lnSpc>
-              <a:spcBef>
-                <a:spcPts val="0"/>
-              </a:spcBef>
-              <a:spcAft>
-                <a:spcPts val="0"/>
-              </a:spcAft>
-            </a:pPr>
-            <a:r>
-              <a:rPr sz="1200">
+            <a:r>
+              <a:rPr sz="1400">
                 <a:latin typeface="Consolas"/>
               </a:rPr>
               <a:t>}</a:t>
             </a:r>
           </a:p>
           <a:p>
-            <a:pPr>
-              <a:lnSpc>
-                <a:spcPct val="100000"/>
-              </a:lnSpc>
-              <a:spcBef>
-                <a:spcPts val="0"/>
-              </a:spcBef>
-              <a:spcAft>
-                <a:spcPts val="0"/>
-              </a:spcAft>
-            </a:pPr>
-            <a:r>
-              <a:rPr sz="1200">
+            <a:r>
+              <a:rPr sz="1400">
                 <a:latin typeface="Consolas"/>
               </a:rPr>
               <a:t>// Factory für Flyweight-Management</a:t>
             </a:r>
           </a:p>
           <a:p>
-            <a:pPr>
-              <a:lnSpc>
-                <a:spcPct val="100000"/>
-              </a:lnSpc>
-              <a:spcBef>
-                <a:spcPts val="0"/>
-              </a:spcBef>
-              <a:spcAft>
-                <a:spcPts val="0"/>
-              </a:spcAft>
-            </a:pPr>
-            <a:r>
-              <a:rPr sz="1200">
+            <a:r>
+              <a:rPr sz="1400">
                 <a:latin typeface="Consolas"/>
               </a:rPr>
               <a:t>@Component</a:t>
             </a:r>
           </a:p>
           <a:p>
-            <a:pPr>
-              <a:lnSpc>
-                <a:spcPct val="100000"/>
-              </a:lnSpc>
-              <a:spcBef>
-                <a:spcPts val="0"/>
-              </a:spcBef>
-              <a:spcAft>
-                <a:spcPts val="0"/>
-              </a:spcAft>
-            </a:pPr>
-            <a:r>
-              <a:rPr sz="1200">
+            <a:r>
+              <a:rPr sz="1400">
                 <a:latin typeface="Consolas"/>
               </a:rPr>
               <a:t>public class TariffPlanFlyweightFactory {</a:t>
             </a:r>
           </a:p>
           <a:p>
-            <a:pPr>
-              <a:lnSpc>
-                <a:spcPct val="100000"/>
-              </a:lnSpc>
-              <a:spcBef>
-                <a:spcPts val="0"/>
-              </a:spcBef>
-              <a:spcAft>
-                <a:spcPts val="0"/>
-              </a:spcAft>
-            </a:pPr>
-            <a:r>
-              <a:rPr sz="1200">
-                <a:latin typeface="Consolas"/>
-              </a:rPr>
-              <a:t>    private final Map&lt;String, TariffPlanFlyweight&gt; flyweights = new ConcurrentHashMap&lt;&gt;();</a:t>
-            </a:r>
-          </a:p>
-          <a:p>
-            <a:pPr>
-              <a:lnSpc>
-                <a:spcPct val="100000"/>
-              </a:lnSpc>
-              <a:spcBef>
-                <a:spcPts val="0"/>
-              </a:spcBef>
-              <a:spcAft>
-                <a:spcPts val="0"/>
-              </a:spcAft>
-            </a:pPr>
-            <a:r>
-              <a:rPr sz="1200">
+            <a:r>
+              <a:rPr sz="1400">
+                <a:latin typeface="Consolas"/>
+              </a:rPr>
+              <a:t>    private final Map flyweights = new ConcurrentHashMap&lt;&gt;();</a:t>
+            </a:r>
+          </a:p>
+          <a:p>
+            <a:r>
+              <a:rPr sz="1400">
                 <a:latin typeface="Consolas"/>
               </a:rPr>
               <a:t>    public TariffPlanFlyweight getTariffPlan(String planName) {</a:t>
             </a:r>
           </a:p>
           <a:p>
-            <a:pPr>
-              <a:lnSpc>
-                <a:spcPct val="100000"/>
-              </a:lnSpc>
-              <a:spcBef>
-                <a:spcPts val="0"/>
-              </a:spcBef>
-              <a:spcAft>
-                <a:spcPts val="0"/>
-              </a:spcAft>
-            </a:pPr>
-            <a:r>
-              <a:rPr sz="1200">
+            <a:r>
+              <a:rPr sz="1400">
                 <a:latin typeface="Consolas"/>
               </a:rPr>
               <a:t>        return flyweights.computeIfAbsent(planName, this::createTariffPlan);</a:t>
             </a:r>
           </a:p>
           <a:p>
-            <a:pPr>
-              <a:lnSpc>
-                <a:spcPct val="100000"/>
-              </a:lnSpc>
-              <a:spcBef>
-                <a:spcPts val="0"/>
-              </a:spcBef>
-              <a:spcAft>
-                <a:spcPts val="0"/>
-              </a:spcAft>
-            </a:pPr>
-            <a:r>
-              <a:rPr sz="1200">
+            <a:r>
+              <a:rPr sz="1400">
                 <a:latin typeface="Consolas"/>
               </a:rPr>
               <a:t>    }</a:t>
             </a:r>
           </a:p>
           <a:p>
-            <a:pPr>
-              <a:lnSpc>
-                <a:spcPct val="100000"/>
-              </a:lnSpc>
-              <a:spcBef>
-                <a:spcPts val="0"/>
-              </a:spcBef>
-              <a:spcAft>
-                <a:spcPts val="0"/>
-              </a:spcAft>
-            </a:pPr>
-            <a:r>
-              <a:rPr sz="1200">
+            <a:r>
+              <a:rPr sz="1400">
                 <a:latin typeface="Consolas"/>
               </a:rPr>
               <a:t>}</a:t>
@@ -8513,7 +8135,7 @@
             <a:spLocks noGrp="1"/>
           </p:cNvSpPr>
           <p:nvPr>
-            <p:ph type="ctrTitle"/>
+            <p:ph type="title"/>
           </p:nvPr>
         </p:nvSpPr>
         <p:spPr/>
@@ -8522,9 +8144,6 @@
           <a:lstStyle/>
           <a:p>
             <a:r>
-              <a:rPr sz="3600" b="1">
-                <a:latin typeface="Calibri"/>
-              </a:rPr>
               <a:t>Pattern-Integration &amp; Enterprise-Readiness</a:t>
             </a:r>
           </a:p>
@@ -8532,19 +8151,53 @@
       </p:sp>
       <p:sp>
         <p:nvSpPr>
-          <p:cNvPr id="3" name="Subtitle 2"/>
-          <p:cNvSpPr>
-            <a:spLocks noGrp="1"/>
-          </p:cNvSpPr>
-          <p:nvPr>
-            <p:ph type="subTitle" idx="1"/>
+          <p:cNvPr id="3" name="Content Placeholder 2"/>
+          <p:cNvSpPr>
+            <a:spLocks noGrp="1"/>
+          </p:cNvSpPr>
+          <p:nvPr>
+            <p:ph idx="1"/>
           </p:nvPr>
         </p:nvSpPr>
         <p:spPr/>
         <p:txBody>
           <a:bodyPr/>
           <a:lstStyle/>
-          <a:p/>
+          <a:p>
+            <a:r>
+              <a:t>Decorator + Strategy**: Optionale, austauschbare Algorithmen kombinieren</a:t>
+            </a:r>
+          </a:p>
+          <a:p>
+            <a:r>
+              <a:t>Composite + Visitor**: Performance-optimierte Hierarchie-Traversierung</a:t>
+            </a:r>
+          </a:p>
+          <a:p>
+            <a:r>
+              <a:t>Facade + Circuit Breaker**: Resiliente Service-Orchestrierung</a:t>
+            </a:r>
+          </a:p>
+          <a:p>
+            <a:r>
+              <a:t>Proxy + Flyweight**: Memory-effiziente Performance-Optimierung</a:t>
+            </a:r>
+          </a:p>
+          <a:p>
+            <a:r>
+              <a:t>Bridge + Factory**: Dynamische Provider-Auswahl mit Abstraktion</a:t>
+            </a:r>
+          </a:p>
+          <a:p>
+            <a:r>
+              <a:t>Template Method Integration**: Konsistente Flows über alle Patterns</a:t>
+            </a:r>
+          </a:p>
+          <a:p>
+            <a:r>
+              <a:t>Event-Driven Enhancement**: Eventual Consistency für komplexe Systeme</a:t>
+            </a:r>
+          </a:p>
         </p:txBody>
       </p:sp>
     </p:spTree>
@@ -8581,10 +8234,7 @@
           <a:lstStyle/>
           <a:p>
             <a:r>
-              <a:rPr sz="2800" b="1">
-                <a:latin typeface="Calibri"/>
-              </a:rPr>
-              <a:t>Production-Ready Considerations</a:t>
+              <a:t>Slide 22: Production-Ready Considerations</a:t>
             </a:r>
           </a:p>
         </p:txBody>
@@ -8604,66 +8254,38 @@
           <a:bodyPr/>
           <a:lstStyle/>
           <a:p>
-            <a:pPr/>
-            <a:r>
-              <a:rPr sz="1600">
-                <a:latin typeface="Calibri"/>
-              </a:rPr>
-              <a:t>**Distributed Caching**: Redis für Multi-Instance Cache-Konsistenz</a:t>
-            </a:r>
-          </a:p>
-          <a:p>
-            <a:pPr/>
-            <a:r>
-              <a:rPr sz="1600">
-                <a:latin typeface="Calibri"/>
-              </a:rPr>
-              <a:t>**Circuit Breaker**: Resilience bei Provider-Integration</a:t>
-            </a:r>
-          </a:p>
-          <a:p>
-            <a:pPr/>
-            <a:r>
-              <a:rPr sz="1600">
-                <a:latin typeface="Calibri"/>
-              </a:rPr>
-              <a:t>**Health Monitoring**: Proaktive Performance- und Verfügbarkeits-Überwachung</a:t>
-            </a:r>
-          </a:p>
-          <a:p>
-            <a:pPr/>
-            <a:r>
-              <a:rPr sz="1600">
-                <a:latin typeface="Calibri"/>
-              </a:rPr>
-              <a:t>**Cache Warming**: Predictive Loading für kritische Daten</a:t>
-            </a:r>
-          </a:p>
-          <a:p>
-            <a:pPr/>
-            <a:r>
-              <a:rPr sz="1600">
-                <a:latin typeface="Calibri"/>
-              </a:rPr>
-              <a:t>**Graceful Degradation**: Fallback-Strategien für Provider-Ausfälle</a:t>
-            </a:r>
-          </a:p>
-          <a:p>
-            <a:pPr/>
-            <a:r>
-              <a:rPr sz="1600">
-                <a:latin typeface="Calibri"/>
-              </a:rPr>
-              <a:t>**Memory Monitoring**: JVM-Metriken und Alerting für Memory-Patterns</a:t>
-            </a:r>
-          </a:p>
-          <a:p>
-            <a:pPr/>
-            <a:r>
-              <a:rPr sz="1600">
-                <a:latin typeface="Calibri"/>
-              </a:rPr>
-              <a:t>**Event Sourcing**: Audit-Trail und System-Konsistenz</a:t>
+            <a:r>
+              <a:t>Distributed Caching**: Redis für Multi-Instance Cache-Konsistenz</a:t>
+            </a:r>
+          </a:p>
+          <a:p>
+            <a:r>
+              <a:t>Circuit Breaker**: Resilience bei Provider-Integration</a:t>
+            </a:r>
+          </a:p>
+          <a:p>
+            <a:r>
+              <a:t>Health Monitoring**: Proaktive Performance- und Verfügbarkeits-Überwachung</a:t>
+            </a:r>
+          </a:p>
+          <a:p>
+            <a:r>
+              <a:t>Cache Warming**: Predictive Loading für kritische Daten</a:t>
+            </a:r>
+          </a:p>
+          <a:p>
+            <a:r>
+              <a:t>Graceful Degradation**: Fallback-Strategien für Provider-Ausfälle</a:t>
+            </a:r>
+          </a:p>
+          <a:p>
+            <a:r>
+              <a:t>Memory Monitoring**: JVM-Metriken und Alerting für Memory-Patterns</a:t>
+            </a:r>
+          </a:p>
+          <a:p>
+            <a:r>
+              <a:t>Event Sourcing**: Audit-Trail und System-Konsistenz</a:t>
             </a:r>
           </a:p>
         </p:txBody>
@@ -8693,7 +8315,7 @@
             <a:spLocks noGrp="1"/>
           </p:cNvSpPr>
           <p:nvPr>
-            <p:ph type="ctrTitle"/>
+            <p:ph type="title"/>
           </p:nvPr>
         </p:nvSpPr>
         <p:spPr/>
@@ -8702,29 +8324,97 @@
           <a:lstStyle/>
           <a:p>
             <a:r>
-              <a:rPr sz="3600" b="1">
-                <a:latin typeface="Calibri"/>
-              </a:rPr>
-              <a:t> Zusammenfassung: Block 2 Erkenntnisse</a:t>
-            </a:r>
-          </a:p>
-        </p:txBody>
-      </p:sp>
-      <p:sp>
-        <p:nvSpPr>
-          <p:cNvPr id="3" name="Subtitle 2"/>
-          <p:cNvSpPr>
-            <a:spLocks noGrp="1"/>
-          </p:cNvSpPr>
-          <p:nvPr>
-            <p:ph type="subTitle" idx="1"/>
+              <a:t>Zusammenfassung: Block 2 Erkenntnisse</a:t>
+            </a:r>
+          </a:p>
+        </p:txBody>
+      </p:sp>
+      <p:sp>
+        <p:nvSpPr>
+          <p:cNvPr id="3" name="Content Placeholder 2"/>
+          <p:cNvSpPr>
+            <a:spLocks noGrp="1"/>
+          </p:cNvSpPr>
+          <p:nvPr>
+            <p:ph idx="1"/>
           </p:nvPr>
         </p:nvSpPr>
         <p:spPr/>
         <p:txBody>
           <a:bodyPr/>
           <a:lstStyle/>
-          <a:p/>
+          <a:p>
+            <a:r>
+              <a:t>✅ </a:t>
+            </a:r>
+            <a:r>
+              <a:rPr b="1"/>
+              <a:t>Strukturelle Probleme elegant lösen</a:t>
+            </a:r>
+            <a:r>
+              <a:t>: Patterns adressieren fundamentale Kompositions-Herausforderungen</a:t>
+            </a:r>
+          </a:p>
+          <a:p>
+            <a:r>
+              <a:t>✅ </a:t>
+            </a:r>
+            <a:r>
+              <a:rPr b="1"/>
+              <a:t>Performance durch Design</a:t>
+            </a:r>
+            <a:r>
+              <a:t>: Memory-Optimierung und Latenz-Reduktion als architektonische Entscheidung</a:t>
+            </a:r>
+          </a:p>
+          <a:p>
+            <a:r>
+              <a:t>✅ </a:t>
+            </a:r>
+            <a:r>
+              <a:rPr b="1"/>
+              <a:t>Enterprise-Skalierung</a:t>
+            </a:r>
+            <a:r>
+              <a:t>: Patterns skalieren mit bewusster Implementierung bis zu 50M+ Kunden</a:t>
+            </a:r>
+          </a:p>
+          <a:p>
+            <a:r>
+              <a:t>✅ </a:t>
+            </a:r>
+            <a:r>
+              <a:rPr b="1"/>
+              <a:t>Microservice-Integration</a:t>
+            </a:r>
+            <a:r>
+              <a:t>: Loose Coupling und Provider-Abstraktion für resiliente Systeme</a:t>
+            </a:r>
+          </a:p>
+          <a:p>
+            <a:r>
+              <a:t>✅ </a:t>
+            </a:r>
+            <a:r>
+              <a:rPr b="1"/>
+              <a:t>Pattern-Kombination</a:t>
+            </a:r>
+            <a:r>
+              <a:t>: Synergien zwischen Patterns multiplizieren architektonischen Wert</a:t>
+            </a:r>
+          </a:p>
+          <a:p>
+            <a:r>
+              <a:t>✅ </a:t>
+            </a:r>
+            <a:r>
+              <a:rPr b="1"/>
+              <a:t>Production-Readiness</a:t>
+            </a:r>
+            <a:r>
+              <a:t>: Mit Monitoring, Caching und Resilience enterprise-tauglich</a:t>
+            </a:r>
+          </a:p>
         </p:txBody>
       </p:sp>
     </p:spTree>
@@ -8761,10 +8451,7 @@
           <a:lstStyle/>
           <a:p>
             <a:r>
-              <a:rPr sz="2800" b="1">
-                <a:latin typeface="Calibri"/>
-              </a:rPr>
-              <a:t>Code Smells identifiziert</a:t>
+              <a:t>Slide 2: Code Smells identifiziert</a:t>
             </a:r>
           </a:p>
         </p:txBody>
@@ -8784,66 +8471,38 @@
           <a:bodyPr/>
           <a:lstStyle/>
           <a:p>
-            <a:pPr/>
-            <a:r>
-              <a:rPr sz="1600">
-                <a:latin typeface="Calibri"/>
-              </a:rPr>
-              <a:t>**Klassen-Explosion**: Bei n Features entstehen 2^n Klassen</a:t>
-            </a:r>
-          </a:p>
-          <a:p>
-            <a:pPr/>
-            <a:r>
-              <a:rPr sz="1600">
-                <a:latin typeface="Calibri"/>
-              </a:rPr>
-              <a:t>**Code-Duplikation**: Bugfixes müssen in hunderten Klassen repliziert werden</a:t>
-            </a:r>
-          </a:p>
-          <a:p>
-            <a:pPr/>
-            <a:r>
-              <a:rPr sz="1600">
-                <a:latin typeface="Calibri"/>
-              </a:rPr>
-              <a:t>**Open/Closed Verletzung**: Jede neue Option erfordert Dutzende neuer Klassen</a:t>
-            </a:r>
-          </a:p>
-          <a:p>
-            <a:pPr/>
-            <a:r>
-              <a:rPr sz="1600">
-                <a:latin typeface="Calibri"/>
-              </a:rPr>
-              <a:t>**Wartungs-Alptraum**: Änderungen propagieren durch die gesamte Hierarchie</a:t>
-            </a:r>
-          </a:p>
-          <a:p>
-            <a:pPr/>
-            <a:r>
-              <a:rPr sz="1600">
-                <a:latin typeface="Calibri"/>
-              </a:rPr>
-              <a:t>**Kombinatorisches Problem**: Unmöglich alle Feature-Kombinationen zu modellieren</a:t>
-            </a:r>
-          </a:p>
-          <a:p>
-            <a:pPr/>
-            <a:r>
-              <a:rPr sz="1600">
-                <a:latin typeface="Calibri"/>
-              </a:rPr>
-              <a:t>**Tight Coupling**: Features sind fest mit Basis-Implementierung gekoppelt</a:t>
-            </a:r>
-          </a:p>
-          <a:p>
-            <a:pPr/>
-            <a:r>
-              <a:rPr sz="1600">
-                <a:latin typeface="Calibri"/>
-              </a:rPr>
-              <a:t>**Inflexibilität**: Keine zur-Laufzeit-Konfiguration von Features möglich</a:t>
+            <a:r>
+              <a:t>Klassen-Explosion**: Bei n Features entstehen 2^n Klassen</a:t>
+            </a:r>
+          </a:p>
+          <a:p>
+            <a:r>
+              <a:t>Code-Duplikation**: Bugfixes müssen in hunderten Klassen repliziert werden</a:t>
+            </a:r>
+          </a:p>
+          <a:p>
+            <a:r>
+              <a:t>Open/Closed Verletzung**: Jede neue Option erfordert Dutzende neuer Klassen</a:t>
+            </a:r>
+          </a:p>
+          <a:p>
+            <a:r>
+              <a:t>Wartungs-Alptraum**: Änderungen propagieren durch die gesamte Hierarchie</a:t>
+            </a:r>
+          </a:p>
+          <a:p>
+            <a:r>
+              <a:t>Kombinatorisches Problem**: Unmöglich alle Feature-Kombinationen zu modellieren</a:t>
+            </a:r>
+          </a:p>
+          <a:p>
+            <a:r>
+              <a:t>Tight Coupling**: Features sind fest mit Basis-Implementierung gekoppelt</a:t>
+            </a:r>
+          </a:p>
+          <a:p>
+            <a:r>
+              <a:t>Inflexibilität**: Keine zur-Laufzeit-Konfiguration von Features möglich</a:t>
             </a:r>
           </a:p>
         </p:txBody>
@@ -8882,10 +8541,7 @@
           <a:lstStyle/>
           <a:p>
             <a:r>
-              <a:rPr sz="2800" b="1">
-                <a:latin typeface="Calibri"/>
-              </a:rPr>
-              <a:t>Lösung: Decorator Pattern</a:t>
+              <a:t>Slide 3: Lösung: Decorator Pattern</a:t>
             </a:r>
           </a:p>
         </p:txBody>
@@ -8905,66 +8561,38 @@
           <a:bodyPr/>
           <a:lstStyle/>
           <a:p>
-            <a:pPr/>
-            <a:r>
-              <a:rPr sz="1600">
-                <a:latin typeface="Calibri"/>
-              </a:rPr>
-              <a:t>**Komposition über Vererbung**: Objekte zur Laufzeit "umhüllen"</a:t>
-            </a:r>
-          </a:p>
-          <a:p>
-            <a:pPr/>
-            <a:r>
-              <a:rPr sz="1600">
-                <a:latin typeface="Calibri"/>
-              </a:rPr>
-              <a:t>**Gemeinsame Schnittstelle**: Component-Interface für einheitliche Behandlung</a:t>
-            </a:r>
-          </a:p>
-          <a:p>
-            <a:pPr/>
-            <a:r>
-              <a:rPr sz="1600">
-                <a:latin typeface="Calibri"/>
-              </a:rPr>
-              <a:t>**Transparente Erweiterung**: Decorators sind für Clients unsichtbar</a:t>
-            </a:r>
-          </a:p>
-          <a:p>
-            <a:pPr/>
-            <a:r>
-              <a:rPr sz="1600">
-                <a:latin typeface="Calibri"/>
-              </a:rPr>
-              <a:t>**Beliebige Kombinierbarkeit**: Features können flexibel kombiniert werden</a:t>
-            </a:r>
-          </a:p>
-          <a:p>
-            <a:pPr/>
-            <a:r>
-              <a:rPr sz="1600">
-                <a:latin typeface="Calibri"/>
-              </a:rPr>
-              <a:t>**Einzelne Verantwortung**: Jeder Decorator fügt genau ein Feature hinzu</a:t>
-            </a:r>
-          </a:p>
-          <a:p>
-            <a:pPr/>
-            <a:r>
-              <a:rPr sz="1600">
-                <a:latin typeface="Calibri"/>
-              </a:rPr>
-              <a:t>**Zur-Laufzeit-Konfiguration**: Dynamische Objekt-Zusammensetzung</a:t>
-            </a:r>
-          </a:p>
-          <a:p>
-            <a:pPr/>
-            <a:r>
-              <a:rPr sz="1600">
-                <a:latin typeface="Calibri"/>
-              </a:rPr>
-              <a:t>**Template Method Integration**: Abstraktes Decorator-Rückgrat für Standards</a:t>
+            <a:r>
+              <a:t>Komposition über Vererbung**: Objekte zur Laufzeit "umhüllen"</a:t>
+            </a:r>
+          </a:p>
+          <a:p>
+            <a:r>
+              <a:t>Gemeinsame Schnittstelle**: Component-Interface für einheitliche Behandlung</a:t>
+            </a:r>
+          </a:p>
+          <a:p>
+            <a:r>
+              <a:t>Transparente Erweiterung**: Decorators sind für Clients unsichtbar</a:t>
+            </a:r>
+          </a:p>
+          <a:p>
+            <a:r>
+              <a:t>Beliebige Kombinierbarkeit**: Features können flexibel kombiniert werden</a:t>
+            </a:r>
+          </a:p>
+          <a:p>
+            <a:r>
+              <a:t>Einzelne Verantwortung**: Jeder Decorator fügt genau ein Feature hinzu</a:t>
+            </a:r>
+          </a:p>
+          <a:p>
+            <a:r>
+              <a:t>Zur-Laufzeit-Konfiguration**: Dynamische Objekt-Zusammensetzung</a:t>
+            </a:r>
+          </a:p>
+          <a:p>
+            <a:r>
+              <a:t>Template Method Integration**: Abstraktes Decorator-Rückgrat für Standards</a:t>
             </a:r>
           </a:p>
         </p:txBody>
@@ -9003,10 +8631,7 @@
           <a:lstStyle/>
           <a:p>
             <a:r>
-              <a:rPr sz="2800" b="1">
-                <a:latin typeface="Calibri"/>
-              </a:rPr>
-              <a:t>Implementierung</a:t>
+              <a:t>Slide 4: Implementierung</a:t>
             </a:r>
           </a:p>
         </p:txBody>
@@ -9023,383 +8648,163 @@
         </p:nvSpPr>
         <p:spPr/>
         <p:txBody>
-          <a:bodyPr tIns="91440" bIns="91440"/>
+          <a:bodyPr/>
           <a:lstStyle/>
           <a:p>
-            <a:pPr>
-              <a:lnSpc>
-                <a:spcPct val="100000"/>
-              </a:lnSpc>
-              <a:spcBef>
-                <a:spcPts val="0"/>
-              </a:spcBef>
-              <a:spcAft>
-                <a:spcPts val="0"/>
-              </a:spcAft>
-            </a:pPr>
-            <a:r>
-              <a:rPr sz="1200">
+            <a:r>
+              <a:rPr sz="1400">
                 <a:latin typeface="Consolas"/>
               </a:rPr>
               <a:t>// Gemeinsame Schnittstelle</a:t>
             </a:r>
           </a:p>
           <a:p>
-            <a:pPr>
-              <a:lnSpc>
-                <a:spcPct val="100000"/>
-              </a:lnSpc>
-              <a:spcBef>
-                <a:spcPts val="0"/>
-              </a:spcBef>
-              <a:spcAft>
-                <a:spcPts val="0"/>
-              </a:spcAft>
-            </a:pPr>
-            <a:r>
-              <a:rPr sz="1200">
+            <a:r>
+              <a:rPr sz="1400">
                 <a:latin typeface="Consolas"/>
               </a:rPr>
               <a:t>public interface TariffService {</a:t>
             </a:r>
           </a:p>
           <a:p>
-            <a:pPr>
-              <a:lnSpc>
-                <a:spcPct val="100000"/>
-              </a:lnSpc>
-              <a:spcBef>
-                <a:spcPts val="0"/>
-              </a:spcBef>
-              <a:spcAft>
-                <a:spcPts val="0"/>
-              </a:spcAft>
-            </a:pPr>
-            <a:r>
-              <a:rPr sz="1200">
+            <a:r>
+              <a:rPr sz="1400">
                 <a:latin typeface="Consolas"/>
               </a:rPr>
               <a:t>    BigDecimal calculatePrice();</a:t>
             </a:r>
           </a:p>
           <a:p>
-            <a:pPr>
-              <a:lnSpc>
-                <a:spcPct val="100000"/>
-              </a:lnSpc>
-              <a:spcBef>
-                <a:spcPts val="0"/>
-              </a:spcBef>
-              <a:spcAft>
-                <a:spcPts val="0"/>
-              </a:spcAft>
-            </a:pPr>
-            <a:r>
-              <a:rPr sz="1200">
-                <a:latin typeface="Consolas"/>
-              </a:rPr>
-              <a:t>    Set&lt;String&gt; getFeatures(); </a:t>
-            </a:r>
-          </a:p>
-          <a:p>
-            <a:pPr>
-              <a:lnSpc>
-                <a:spcPct val="100000"/>
-              </a:lnSpc>
-              <a:spcBef>
-                <a:spcPts val="0"/>
-              </a:spcBef>
-              <a:spcAft>
-                <a:spcPts val="0"/>
-              </a:spcAft>
-            </a:pPr>
-            <a:r>
-              <a:rPr sz="1200">
+            <a:r>
+              <a:rPr sz="1400">
+                <a:latin typeface="Consolas"/>
+              </a:rPr>
+              <a:t>    Set getFeatures(); </a:t>
+            </a:r>
+          </a:p>
+          <a:p>
+            <a:r>
+              <a:rPr sz="1400">
                 <a:latin typeface="Consolas"/>
               </a:rPr>
               <a:t>}</a:t>
             </a:r>
           </a:p>
           <a:p>
-            <a:pPr>
-              <a:lnSpc>
-                <a:spcPct val="100000"/>
-              </a:lnSpc>
-              <a:spcBef>
-                <a:spcPts val="0"/>
-              </a:spcBef>
-              <a:spcAft>
-                <a:spcPts val="0"/>
-              </a:spcAft>
-            </a:pPr>
-            <a:r>
-              <a:rPr sz="1200">
+            <a:r>
+              <a:rPr sz="1400">
                 <a:latin typeface="Consolas"/>
               </a:rPr>
               <a:t>// Abstrakter Decorator</a:t>
             </a:r>
           </a:p>
           <a:p>
-            <a:pPr>
-              <a:lnSpc>
-                <a:spcPct val="100000"/>
-              </a:lnSpc>
-              <a:spcBef>
-                <a:spcPts val="0"/>
-              </a:spcBef>
-              <a:spcAft>
-                <a:spcPts val="0"/>
-              </a:spcAft>
-            </a:pPr>
-            <a:r>
-              <a:rPr sz="1200">
+            <a:r>
+              <a:rPr sz="1400">
                 <a:latin typeface="Consolas"/>
               </a:rPr>
               <a:t>public abstract class TariffDecorator implements TariffService {</a:t>
             </a:r>
           </a:p>
           <a:p>
-            <a:pPr>
-              <a:lnSpc>
-                <a:spcPct val="100000"/>
-              </a:lnSpc>
-              <a:spcBef>
-                <a:spcPts val="0"/>
-              </a:spcBef>
-              <a:spcAft>
-                <a:spcPts val="0"/>
-              </a:spcAft>
-            </a:pPr>
-            <a:r>
-              <a:rPr sz="1200">
+            <a:r>
+              <a:rPr sz="1400">
                 <a:latin typeface="Consolas"/>
               </a:rPr>
               <a:t>    protected final TariffService decoratedTariff;</a:t>
             </a:r>
           </a:p>
           <a:p>
-            <a:pPr>
-              <a:lnSpc>
-                <a:spcPct val="100000"/>
-              </a:lnSpc>
-              <a:spcBef>
-                <a:spcPts val="0"/>
-              </a:spcBef>
-              <a:spcAft>
-                <a:spcPts val="0"/>
-              </a:spcAft>
-            </a:pPr>
-            <a:r>
-              <a:rPr sz="1200">
+            <a:r>
+              <a:rPr sz="1400">
                 <a:latin typeface="Consolas"/>
               </a:rPr>
               <a:t>    public BigDecimal calculatePrice() {</a:t>
             </a:r>
           </a:p>
           <a:p>
-            <a:pPr>
-              <a:lnSpc>
-                <a:spcPct val="100000"/>
-              </a:lnSpc>
-              <a:spcBef>
-                <a:spcPts val="0"/>
-              </a:spcBef>
-              <a:spcAft>
-                <a:spcPts val="0"/>
-              </a:spcAft>
-            </a:pPr>
-            <a:r>
-              <a:rPr sz="1200">
+            <a:r>
+              <a:rPr sz="1400">
                 <a:latin typeface="Consolas"/>
               </a:rPr>
               <a:t>        return decoratedTariff.calculatePrice(); // Delegation</a:t>
             </a:r>
           </a:p>
           <a:p>
-            <a:pPr>
-              <a:lnSpc>
-                <a:spcPct val="100000"/>
-              </a:lnSpc>
-              <a:spcBef>
-                <a:spcPts val="0"/>
-              </a:spcBef>
-              <a:spcAft>
-                <a:spcPts val="0"/>
-              </a:spcAft>
-            </a:pPr>
-            <a:r>
-              <a:rPr sz="1200">
+            <a:r>
+              <a:rPr sz="1400">
                 <a:latin typeface="Consolas"/>
               </a:rPr>
               <a:t>    }</a:t>
             </a:r>
           </a:p>
           <a:p>
-            <a:pPr>
-              <a:lnSpc>
-                <a:spcPct val="100000"/>
-              </a:lnSpc>
-              <a:spcBef>
-                <a:spcPts val="0"/>
-              </a:spcBef>
-              <a:spcAft>
-                <a:spcPts val="0"/>
-              </a:spcAft>
-            </a:pPr>
-            <a:r>
-              <a:rPr sz="1200">
+            <a:r>
+              <a:rPr sz="1400">
                 <a:latin typeface="Consolas"/>
               </a:rPr>
               <a:t>}</a:t>
             </a:r>
           </a:p>
           <a:p>
-            <a:pPr>
-              <a:lnSpc>
-                <a:spcPct val="100000"/>
-              </a:lnSpc>
-              <a:spcBef>
-                <a:spcPts val="0"/>
-              </a:spcBef>
-              <a:spcAft>
-                <a:spcPts val="0"/>
-              </a:spcAft>
-            </a:pPr>
-            <a:r>
-              <a:rPr sz="1200">
+            <a:r>
+              <a:rPr sz="1400">
                 <a:latin typeface="Consolas"/>
               </a:rPr>
               <a:t>// Konkreter Decorator  </a:t>
             </a:r>
           </a:p>
           <a:p>
-            <a:pPr>
-              <a:lnSpc>
-                <a:spcPct val="100000"/>
-              </a:lnSpc>
-              <a:spcBef>
-                <a:spcPts val="0"/>
-              </a:spcBef>
-              <a:spcAft>
-                <a:spcPts val="0"/>
-              </a:spcAft>
-            </a:pPr>
-            <a:r>
-              <a:rPr sz="1200">
+            <a:r>
+              <a:rPr sz="1400">
                 <a:latin typeface="Consolas"/>
               </a:rPr>
               <a:t>public class DataOptionDecorator extends TariffDecorator {</a:t>
             </a:r>
           </a:p>
           <a:p>
-            <a:pPr>
-              <a:lnSpc>
-                <a:spcPct val="100000"/>
-              </a:lnSpc>
-              <a:spcBef>
-                <a:spcPts val="0"/>
-              </a:spcBef>
-              <a:spcAft>
-                <a:spcPts val="0"/>
-              </a:spcAft>
-            </a:pPr>
-            <a:r>
-              <a:rPr sz="1200">
+            <a:r>
+              <a:rPr sz="1400">
                 <a:latin typeface="Consolas"/>
               </a:rPr>
               <a:t>    private final BigDecimal dataPrice;</a:t>
             </a:r>
           </a:p>
           <a:p>
-            <a:pPr>
-              <a:lnSpc>
-                <a:spcPct val="100000"/>
-              </a:lnSpc>
-              <a:spcBef>
-                <a:spcPts val="0"/>
-              </a:spcBef>
-              <a:spcAft>
-                <a:spcPts val="0"/>
-              </a:spcAft>
-            </a:pPr>
-            <a:r>
-              <a:rPr sz="1200">
+            <a:r>
+              <a:rPr sz="1400">
                 <a:latin typeface="Consolas"/>
               </a:rPr>
               <a:t>    @Override</a:t>
             </a:r>
           </a:p>
           <a:p>
-            <a:pPr>
-              <a:lnSpc>
-                <a:spcPct val="100000"/>
-              </a:lnSpc>
-              <a:spcBef>
-                <a:spcPts val="0"/>
-              </a:spcBef>
-              <a:spcAft>
-                <a:spcPts val="0"/>
-              </a:spcAft>
-            </a:pPr>
-            <a:r>
-              <a:rPr sz="1200">
+            <a:r>
+              <a:rPr sz="1400">
                 <a:latin typeface="Consolas"/>
               </a:rPr>
               <a:t>    public BigDecimal calculatePrice() {</a:t>
             </a:r>
           </a:p>
           <a:p>
-            <a:pPr>
-              <a:lnSpc>
-                <a:spcPct val="100000"/>
-              </a:lnSpc>
-              <a:spcBef>
-                <a:spcPts val="0"/>
-              </a:spcBef>
-              <a:spcAft>
-                <a:spcPts val="0"/>
-              </a:spcAft>
-            </a:pPr>
-            <a:r>
-              <a:rPr sz="1200">
+            <a:r>
+              <a:rPr sz="1400">
                 <a:latin typeface="Consolas"/>
               </a:rPr>
               <a:t>        return super.calculatePrice().add(dataPrice); // Erweiterung</a:t>
             </a:r>
           </a:p>
           <a:p>
-            <a:pPr>
-              <a:lnSpc>
-                <a:spcPct val="100000"/>
-              </a:lnSpc>
-              <a:spcBef>
-                <a:spcPts val="0"/>
-              </a:spcBef>
-              <a:spcAft>
-                <a:spcPts val="0"/>
-              </a:spcAft>
-            </a:pPr>
-            <a:r>
-              <a:rPr sz="1200">
+            <a:r>
+              <a:rPr sz="1400">
                 <a:latin typeface="Consolas"/>
               </a:rPr>
               <a:t>    }</a:t>
             </a:r>
           </a:p>
           <a:p>
-            <a:pPr>
-              <a:lnSpc>
-                <a:spcPct val="100000"/>
-              </a:lnSpc>
-              <a:spcBef>
-                <a:spcPts val="0"/>
-              </a:spcBef>
-              <a:spcAft>
-                <a:spcPts val="0"/>
-              </a:spcAft>
-            </a:pPr>
-            <a:r>
-              <a:rPr sz="1200">
+            <a:r>
+              <a:rPr sz="1400">
                 <a:latin typeface="Consolas"/>
               </a:rPr>
               <a:t>}</a:t>
@@ -9432,7 +8837,7 @@
             <a:spLocks noGrp="1"/>
           </p:cNvSpPr>
           <p:nvPr>
-            <p:ph type="ctrTitle"/>
+            <p:ph type="title"/>
           </p:nvPr>
         </p:nvSpPr>
         <p:spPr/>
@@ -9441,9 +8846,6 @@
           <a:lstStyle/>
           <a:p>
             <a:r>
-              <a:rPr sz="3600" b="1">
-                <a:latin typeface="Calibri"/>
-              </a:rPr>
               <a:t>Composite Pattern</a:t>
             </a:r>
           </a:p>
@@ -9451,19 +8853,146 @@
       </p:sp>
       <p:sp>
         <p:nvSpPr>
-          <p:cNvPr id="3" name="Subtitle 2"/>
-          <p:cNvSpPr>
-            <a:spLocks noGrp="1"/>
-          </p:cNvSpPr>
-          <p:nvPr>
-            <p:ph type="subTitle" idx="1"/>
+          <p:cNvPr id="3" name="Content Placeholder 2"/>
+          <p:cNvSpPr>
+            <a:spLocks noGrp="1"/>
+          </p:cNvSpPr>
+          <p:nvPr>
+            <p:ph idx="1"/>
           </p:nvPr>
         </p:nvSpPr>
         <p:spPr/>
         <p:txBody>
           <a:bodyPr/>
           <a:lstStyle/>
-          <a:p/>
+          <a:p>
+            <a:r>
+              <a:rPr sz="1400">
+                <a:latin typeface="Consolas"/>
+              </a:rPr>
+              <a:t>// Separate Behandlung für Einzeltarife vs. Gruppen</a:t>
+            </a:r>
+          </a:p>
+          <a:p>
+            <a:r>
+              <a:rPr sz="1400">
+                <a:latin typeface="Consolas"/>
+              </a:rPr>
+              <a:t>public class TariffService {</a:t>
+            </a:r>
+          </a:p>
+          <a:p>
+            <a:r>
+              <a:rPr sz="1400">
+                <a:latin typeface="Consolas"/>
+              </a:rPr>
+              <a:t>    public void processOrder(Object tariff) {</a:t>
+            </a:r>
+          </a:p>
+          <a:p>
+            <a:r>
+              <a:rPr sz="1400">
+                <a:latin typeface="Consolas"/>
+              </a:rPr>
+              <a:t>        if (tariff instanceof IndividualTariff) {</a:t>
+            </a:r>
+          </a:p>
+          <a:p>
+            <a:r>
+              <a:rPr sz="1400">
+                <a:latin typeface="Consolas"/>
+              </a:rPr>
+              <a:t>            IndividualTariff individual = (IndividualTariff) tariff;</a:t>
+            </a:r>
+          </a:p>
+          <a:p>
+            <a:r>
+              <a:rPr sz="1400">
+                <a:latin typeface="Consolas"/>
+              </a:rPr>
+              <a:t>            // Individuelle Verarbeitung</a:t>
+            </a:r>
+          </a:p>
+          <a:p>
+            <a:r>
+              <a:rPr sz="1400">
+                <a:latin typeface="Consolas"/>
+              </a:rPr>
+              <a:t>        } else if (tariff instanceof FamilyTariff) {</a:t>
+            </a:r>
+          </a:p>
+          <a:p>
+            <a:r>
+              <a:rPr sz="1400">
+                <a:latin typeface="Consolas"/>
+              </a:rPr>
+              <a:t>            FamilyTariff family = (FamilyTariff) tariff;</a:t>
+            </a:r>
+          </a:p>
+          <a:p>
+            <a:r>
+              <a:rPr sz="1400">
+                <a:latin typeface="Consolas"/>
+              </a:rPr>
+              <a:t>            // Familiengruppen-spezifische Logik</a:t>
+            </a:r>
+          </a:p>
+          <a:p>
+            <a:r>
+              <a:rPr sz="1400">
+                <a:latin typeface="Consolas"/>
+              </a:rPr>
+              <a:t>            for (IndividualTariff member : family.getMembers()) {</a:t>
+            </a:r>
+          </a:p>
+          <a:p>
+            <a:r>
+              <a:rPr sz="1400">
+                <a:latin typeface="Consolas"/>
+              </a:rPr>
+              <a:t>                // Rekursive Verarbeitung...</a:t>
+            </a:r>
+          </a:p>
+          <a:p>
+            <a:r>
+              <a:rPr sz="1400">
+                <a:latin typeface="Consolas"/>
+              </a:rPr>
+              <a:t>            }</a:t>
+            </a:r>
+          </a:p>
+          <a:p>
+            <a:r>
+              <a:rPr sz="1400">
+                <a:latin typeface="Consolas"/>
+              </a:rPr>
+              <a:t>        }</a:t>
+            </a:r>
+          </a:p>
+          <a:p>
+            <a:r>
+              <a:rPr sz="1400">
+                <a:latin typeface="Consolas"/>
+              </a:rPr>
+              <a:t>        // Komplexe If-Verschachtelung für alle Tarif-Typen</a:t>
+            </a:r>
+          </a:p>
+          <a:p>
+            <a:r>
+              <a:rPr sz="1400">
+                <a:latin typeface="Consolas"/>
+              </a:rPr>
+              <a:t>    }</a:t>
+            </a:r>
+          </a:p>
+          <a:p>
+            <a:r>
+              <a:rPr sz="1400">
+                <a:latin typeface="Consolas"/>
+              </a:rPr>
+              <a:t>}</a:t>
+            </a:r>
+          </a:p>
         </p:txBody>
       </p:sp>
     </p:spTree>
@@ -9500,10 +9029,7 @@
           <a:lstStyle/>
           <a:p>
             <a:r>
-              <a:rPr sz="2800" b="1">
-                <a:latin typeface="Calibri"/>
-              </a:rPr>
-              <a:t>Code Smells identifiziert</a:t>
+              <a:t>Slide 6: Code Smells identifiziert</a:t>
             </a:r>
           </a:p>
         </p:txBody>
@@ -9523,66 +9049,38 @@
           <a:bodyPr/>
           <a:lstStyle/>
           <a:p>
-            <a:pPr/>
-            <a:r>
-              <a:rPr sz="1600">
-                <a:latin typeface="Calibri"/>
-              </a:rPr>
-              <a:t>**Type-Checking Nightmare**: Instanceof-Checks überall im Code</a:t>
-            </a:r>
-          </a:p>
-          <a:p>
-            <a:pPr/>
-            <a:r>
-              <a:rPr sz="1600">
-                <a:latin typeface="Calibri"/>
-              </a:rPr>
-              <a:t>**Rekursive Logik-Duplikation**: Gleiche Traversierung in jeder Methode</a:t>
-            </a:r>
-          </a:p>
-          <a:p>
-            <a:pPr/>
-            <a:r>
-              <a:rPr sz="1600">
-                <a:latin typeface="Calibri"/>
-              </a:rPr>
-              <a:t>**Kombinatorische Explosion**: Neue Tarif-Typen = neue If-Zweige überall</a:t>
-            </a:r>
-          </a:p>
-          <a:p>
-            <a:pPr/>
-            <a:r>
-              <a:rPr sz="1600">
-                <a:latin typeface="Calibri"/>
-              </a:rPr>
-              <a:t>**Client-Komplexität**: Clients müssen alle Tarif-Typen kennen</a:t>
-            </a:r>
-          </a:p>
-          <a:p>
-            <a:pPr/>
-            <a:r>
-              <a:rPr sz="1600">
-                <a:latin typeface="Calibri"/>
-              </a:rPr>
-              <a:t>**Tight Coupling**: Client-Code gekoppelt an konkrete Tarif-Typen</a:t>
-            </a:r>
-          </a:p>
-          <a:p>
-            <a:pPr/>
-            <a:r>
-              <a:rPr sz="1600">
-                <a:latin typeface="Calibri"/>
-              </a:rPr>
-              <a:t>**Inkonsistente Behandlung**: Verschiedene Logik für ähnliche Operationen</a:t>
-            </a:r>
-          </a:p>
-          <a:p>
-            <a:pPr/>
-            <a:r>
-              <a:rPr sz="1600">
-                <a:latin typeface="Calibri"/>
-              </a:rPr>
-              <a:t>**Schwer erweiterbar**: Neue Hierarchie-Ebenen = massive Code-Änderungen</a:t>
+            <a:r>
+              <a:t>Type-Checking Nightmare**: Instanceof-Checks überall im Code</a:t>
+            </a:r>
+          </a:p>
+          <a:p>
+            <a:r>
+              <a:t>Rekursive Logik-Duplikation**: Gleiche Traversierung in jeder Methode</a:t>
+            </a:r>
+          </a:p>
+          <a:p>
+            <a:r>
+              <a:t>Kombinatorische Explosion**: Neue Tarif-Typen = neue If-Zweige überall</a:t>
+            </a:r>
+          </a:p>
+          <a:p>
+            <a:r>
+              <a:t>Client-Komplexität**: Clients müssen alle Tarif-Typen kennen</a:t>
+            </a:r>
+          </a:p>
+          <a:p>
+            <a:r>
+              <a:t>Tight Coupling**: Client-Code gekoppelt an konkrete Tarif-Typen</a:t>
+            </a:r>
+          </a:p>
+          <a:p>
+            <a:r>
+              <a:t>Inkonsistente Behandlung**: Verschiedene Logik für ähnliche Operationen</a:t>
+            </a:r>
+          </a:p>
+          <a:p>
+            <a:r>
+              <a:t>Schwer erweiterbar**: Neue Hierarchie-Ebenen = massive Code-Änderungen</a:t>
             </a:r>
           </a:p>
         </p:txBody>
@@ -9621,10 +9119,7 @@
           <a:lstStyle/>
           <a:p>
             <a:r>
-              <a:rPr sz="2800" b="1">
-                <a:latin typeface="Calibri"/>
-              </a:rPr>
-              <a:t>Lösung: Composite Pattern</a:t>
+              <a:t>Slide 7: Lösung: Composite Pattern</a:t>
             </a:r>
           </a:p>
         </p:txBody>
@@ -9644,66 +9139,38 @@
           <a:bodyPr/>
           <a:lstStyle/>
           <a:p>
-            <a:pPr/>
-            <a:r>
-              <a:rPr sz="1600">
-                <a:latin typeface="Calibri"/>
-              </a:rPr>
-              <a:t>**Einheitliche Behandlung**: Einzelobjekte und Sammlungen identisch behandeln</a:t>
-            </a:r>
-          </a:p>
-          <a:p>
-            <a:pPr/>
-            <a:r>
-              <a:rPr sz="1600">
-                <a:latin typeface="Calibri"/>
-              </a:rPr>
-              <a:t>**Rekursive Struktur**: Composites können andere Composites enthalten</a:t>
-            </a:r>
-          </a:p>
-          <a:p>
-            <a:pPr/>
-            <a:r>
-              <a:rPr sz="1600">
-                <a:latin typeface="Calibri"/>
-              </a:rPr>
-              <a:t>**Transparenz für Client**: Client arbeitet nur mit Component-Interface</a:t>
-            </a:r>
-          </a:p>
-          <a:p>
-            <a:pPr/>
-            <a:r>
-              <a:rPr sz="1600">
-                <a:latin typeface="Calibri"/>
-              </a:rPr>
-              <a:t>**Natürliche Hierarchie-Abbildung**: Teil-Ganzes-Beziehungen elegant modelliert</a:t>
-            </a:r>
-          </a:p>
-          <a:p>
-            <a:pPr/>
-            <a:r>
-              <a:rPr sz="1600">
-                <a:latin typeface="Calibri"/>
-              </a:rPr>
-              <a:t>**Liskov Substitution**: Blätter und Äste vollständig austauschbar</a:t>
-            </a:r>
-          </a:p>
-          <a:p>
-            <a:pPr/>
-            <a:r>
-              <a:rPr sz="1600">
-                <a:latin typeface="Calibri"/>
-              </a:rPr>
-              <a:t>**Funktionale Aggregation**: Stream-API macht Traversierung elegant</a:t>
-            </a:r>
-          </a:p>
-          <a:p>
-            <a:pPr/>
-            <a:r>
-              <a:rPr sz="1600">
-                <a:latin typeface="Calibri"/>
-              </a:rPr>
-              <a:t>**Strategy Pattern Integration**: Gruppen-Rabatte bleiben austauschbar</a:t>
+            <a:r>
+              <a:t>Einheitliche Behandlung**: Einzelobjekte und Sammlungen identisch behandeln</a:t>
+            </a:r>
+          </a:p>
+          <a:p>
+            <a:r>
+              <a:t>Rekursive Struktur**: Composites können andere Composites enthalten</a:t>
+            </a:r>
+          </a:p>
+          <a:p>
+            <a:r>
+              <a:t>Transparenz für Client**: Client arbeitet nur mit Component-Interface</a:t>
+            </a:r>
+          </a:p>
+          <a:p>
+            <a:r>
+              <a:t>Natürliche Hierarchie-Abbildung**: Teil-Ganzes-Beziehungen elegant modelliert</a:t>
+            </a:r>
+          </a:p>
+          <a:p>
+            <a:r>
+              <a:t>Liskov Substitution**: Blätter und Äste vollständig austauschbar</a:t>
+            </a:r>
+          </a:p>
+          <a:p>
+            <a:r>
+              <a:t>Funktionale Aggregation**: Stream-API macht Traversierung elegant</a:t>
+            </a:r>
+          </a:p>
+          <a:p>
+            <a:r>
+              <a:t>Strategy Pattern Integration**: Gruppen-Rabatte bleiben austauschbar</a:t>
             </a:r>
           </a:p>
         </p:txBody>
@@ -9742,10 +9209,7 @@
           <a:lstStyle/>
           <a:p>
             <a:r>
-              <a:rPr sz="2800" b="1">
-                <a:latin typeface="Calibri"/>
-              </a:rPr>
-              <a:t>Implementierung</a:t>
+              <a:t>Slide 8: Implementierung</a:t>
             </a:r>
           </a:p>
         </p:txBody>
@@ -9762,402 +9226,171 @@
         </p:nvSpPr>
         <p:spPr/>
         <p:txBody>
-          <a:bodyPr tIns="91440" bIns="91440"/>
+          <a:bodyPr/>
           <a:lstStyle/>
           <a:p>
-            <a:pPr>
-              <a:lnSpc>
-                <a:spcPct val="100000"/>
-              </a:lnSpc>
-              <a:spcBef>
-                <a:spcPts val="0"/>
-              </a:spcBef>
-              <a:spcAft>
-                <a:spcPts val="0"/>
-              </a:spcAft>
-            </a:pPr>
-            <a:r>
-              <a:rPr sz="1200">
+            <a:r>
+              <a:rPr sz="1400">
                 <a:latin typeface="Consolas"/>
               </a:rPr>
               <a:t>// Component-Interface</a:t>
             </a:r>
           </a:p>
           <a:p>
-            <a:pPr>
-              <a:lnSpc>
-                <a:spcPct val="100000"/>
-              </a:lnSpc>
-              <a:spcBef>
-                <a:spcPts val="0"/>
-              </a:spcBef>
-              <a:spcAft>
-                <a:spcPts val="0"/>
-              </a:spcAft>
-            </a:pPr>
-            <a:r>
-              <a:rPr sz="1200">
+            <a:r>
+              <a:rPr sz="1400">
                 <a:latin typeface="Consolas"/>
               </a:rPr>
               <a:t>public interface TariffComponent {</a:t>
             </a:r>
           </a:p>
           <a:p>
-            <a:pPr>
-              <a:lnSpc>
-                <a:spcPct val="100000"/>
-              </a:lnSpc>
-              <a:spcBef>
-                <a:spcPts val="0"/>
-              </a:spcBef>
-              <a:spcAft>
-                <a:spcPts val="0"/>
-              </a:spcAft>
-            </a:pPr>
-            <a:r>
-              <a:rPr sz="1200">
+            <a:r>
+              <a:rPr sz="1400">
                 <a:latin typeface="Consolas"/>
               </a:rPr>
               <a:t>    BigDecimal calculateTotalPrice();</a:t>
             </a:r>
           </a:p>
           <a:p>
-            <a:pPr>
-              <a:lnSpc>
-                <a:spcPct val="100000"/>
-              </a:lnSpc>
-              <a:spcBef>
-                <a:spcPts val="0"/>
-              </a:spcBef>
-              <a:spcAft>
-                <a:spcPts val="0"/>
-              </a:spcAft>
-            </a:pPr>
-            <a:r>
-              <a:rPr sz="1200">
-                <a:latin typeface="Consolas"/>
-              </a:rPr>
-              <a:t>    List&lt;String&gt; getAllFeatures();</a:t>
-            </a:r>
-          </a:p>
-          <a:p>
-            <a:pPr>
-              <a:lnSpc>
-                <a:spcPct val="100000"/>
-              </a:lnSpc>
-              <a:spcBef>
-                <a:spcPts val="0"/>
-              </a:spcBef>
-              <a:spcAft>
-                <a:spcPts val="0"/>
-              </a:spcAft>
-            </a:pPr>
-            <a:r>
-              <a:rPr sz="1200">
+            <a:r>
+              <a:rPr sz="1400">
+                <a:latin typeface="Consolas"/>
+              </a:rPr>
+              <a:t>    List getAllFeatures();</a:t>
+            </a:r>
+          </a:p>
+          <a:p>
+            <a:r>
+              <a:rPr sz="1400">
                 <a:latin typeface="Consolas"/>
               </a:rPr>
               <a:t>    int getContractCount();</a:t>
             </a:r>
           </a:p>
           <a:p>
-            <a:pPr>
-              <a:lnSpc>
-                <a:spcPct val="100000"/>
-              </a:lnSpc>
-              <a:spcBef>
-                <a:spcPts val="0"/>
-              </a:spcBef>
-              <a:spcAft>
-                <a:spcPts val="0"/>
-              </a:spcAft>
-            </a:pPr>
-            <a:r>
-              <a:rPr sz="1200">
+            <a:r>
+              <a:rPr sz="1400">
                 <a:latin typeface="Consolas"/>
               </a:rPr>
               <a:t>}</a:t>
             </a:r>
           </a:p>
           <a:p>
-            <a:pPr>
-              <a:lnSpc>
-                <a:spcPct val="100000"/>
-              </a:lnSpc>
-              <a:spcBef>
-                <a:spcPts val="0"/>
-              </a:spcBef>
-              <a:spcAft>
-                <a:spcPts val="0"/>
-              </a:spcAft>
-            </a:pPr>
-            <a:r>
-              <a:rPr sz="1200">
+            <a:r>
+              <a:rPr sz="1400">
                 <a:latin typeface="Consolas"/>
               </a:rPr>
               <a:t>// Composite-Implementierung</a:t>
             </a:r>
           </a:p>
           <a:p>
-            <a:pPr>
-              <a:lnSpc>
-                <a:spcPct val="100000"/>
-              </a:lnSpc>
-              <a:spcBef>
-                <a:spcPts val="0"/>
-              </a:spcBef>
-              <a:spcAft>
-                <a:spcPts val="0"/>
-              </a:spcAft>
-            </a:pPr>
-            <a:r>
-              <a:rPr sz="1200">
+            <a:r>
+              <a:rPr sz="1400">
                 <a:latin typeface="Consolas"/>
               </a:rPr>
               <a:t>public class TariffGroup implements TariffComponent {</a:t>
             </a:r>
           </a:p>
           <a:p>
-            <a:pPr>
-              <a:lnSpc>
-                <a:spcPct val="100000"/>
-              </a:lnSpc>
-              <a:spcBef>
-                <a:spcPts val="0"/>
-              </a:spcBef>
-              <a:spcAft>
-                <a:spcPts val="0"/>
-              </a:spcAft>
-            </a:pPr>
-            <a:r>
-              <a:rPr sz="1200">
-                <a:latin typeface="Consolas"/>
-              </a:rPr>
-              <a:t>    private final List&lt;TariffComponent&gt; children = new ArrayList&lt;&gt;();</a:t>
-            </a:r>
-          </a:p>
-          <a:p>
-            <a:pPr>
-              <a:lnSpc>
-                <a:spcPct val="100000"/>
-              </a:lnSpc>
-              <a:spcBef>
-                <a:spcPts val="0"/>
-              </a:spcBef>
-              <a:spcAft>
-                <a:spcPts val="0"/>
-              </a:spcAft>
-            </a:pPr>
-            <a:r>
-              <a:rPr sz="1200">
+            <a:r>
+              <a:rPr sz="1400">
+                <a:latin typeface="Consolas"/>
+              </a:rPr>
+              <a:t>    private final List children = new ArrayList&lt;&gt;();</a:t>
+            </a:r>
+          </a:p>
+          <a:p>
+            <a:r>
+              <a:rPr sz="1400">
                 <a:latin typeface="Consolas"/>
               </a:rPr>
               <a:t>    public BigDecimal calculateTotalPrice() {</a:t>
             </a:r>
           </a:p>
           <a:p>
-            <a:pPr>
-              <a:lnSpc>
-                <a:spcPct val="100000"/>
-              </a:lnSpc>
-              <a:spcBef>
-                <a:spcPts val="0"/>
-              </a:spcBef>
-              <a:spcAft>
-                <a:spcPts val="0"/>
-              </a:spcAft>
-            </a:pPr>
-            <a:r>
-              <a:rPr sz="1200">
+            <a:r>
+              <a:rPr sz="1400">
                 <a:latin typeface="Consolas"/>
               </a:rPr>
               <a:t>        BigDecimal total = children.stream()</a:t>
             </a:r>
           </a:p>
           <a:p>
-            <a:pPr>
-              <a:lnSpc>
-                <a:spcPct val="100000"/>
-              </a:lnSpc>
-              <a:spcBef>
-                <a:spcPts val="0"/>
-              </a:spcBef>
-              <a:spcAft>
-                <a:spcPts val="0"/>
-              </a:spcAft>
-            </a:pPr>
-            <a:r>
-              <a:rPr sz="1200">
+            <a:r>
+              <a:rPr sz="1400">
                 <a:latin typeface="Consolas"/>
               </a:rPr>
               <a:t>            .map(TariffComponent::calculateTotalPrice)</a:t>
             </a:r>
           </a:p>
           <a:p>
-            <a:pPr>
-              <a:lnSpc>
-                <a:spcPct val="100000"/>
-              </a:lnSpc>
-              <a:spcBef>
-                <a:spcPts val="0"/>
-              </a:spcBef>
-              <a:spcAft>
-                <a:spcPts val="0"/>
-              </a:spcAft>
-            </a:pPr>
-            <a:r>
-              <a:rPr sz="1200">
+            <a:r>
+              <a:rPr sz="1400">
                 <a:latin typeface="Consolas"/>
               </a:rPr>
               <a:t>            .reduce(BigDecimal.ZERO, BigDecimal::add);</a:t>
             </a:r>
           </a:p>
           <a:p>
-            <a:pPr>
-              <a:lnSpc>
-                <a:spcPct val="100000"/>
-              </a:lnSpc>
-              <a:spcBef>
-                <a:spcPts val="0"/>
-              </a:spcBef>
-              <a:spcAft>
-                <a:spcPts val="0"/>
-              </a:spcAft>
-            </a:pPr>
-            <a:r>
-              <a:rPr sz="1200">
+            <a:r>
+              <a:rPr sz="1400">
                 <a:latin typeface="Consolas"/>
               </a:rPr>
               <a:t>        return discountStrategy.applyGroupDiscount(total);</a:t>
             </a:r>
           </a:p>
           <a:p>
-            <a:pPr>
-              <a:lnSpc>
-                <a:spcPct val="100000"/>
-              </a:lnSpc>
-              <a:spcBef>
-                <a:spcPts val="0"/>
-              </a:spcBef>
-              <a:spcAft>
-                <a:spcPts val="0"/>
-              </a:spcAft>
-            </a:pPr>
-            <a:r>
-              <a:rPr sz="1200">
+            <a:r>
+              <a:rPr sz="1400">
                 <a:latin typeface="Consolas"/>
               </a:rPr>
               <a:t>    }</a:t>
             </a:r>
           </a:p>
           <a:p>
-            <a:pPr>
-              <a:lnSpc>
-                <a:spcPct val="100000"/>
-              </a:lnSpc>
-              <a:spcBef>
-                <a:spcPts val="0"/>
-              </a:spcBef>
-              <a:spcAft>
-                <a:spcPts val="0"/>
-              </a:spcAft>
-            </a:pPr>
-            <a:r>
-              <a:rPr sz="1200">
+            <a:r>
+              <a:rPr sz="1400">
                 <a:latin typeface="Consolas"/>
               </a:rPr>
               <a:t>    public int getContractCount() {</a:t>
             </a:r>
           </a:p>
           <a:p>
-            <a:pPr>
-              <a:lnSpc>
-                <a:spcPct val="100000"/>
-              </a:lnSpc>
-              <a:spcBef>
-                <a:spcPts val="0"/>
-              </a:spcBef>
-              <a:spcAft>
-                <a:spcPts val="0"/>
-              </a:spcAft>
-            </a:pPr>
-            <a:r>
-              <a:rPr sz="1200">
+            <a:r>
+              <a:rPr sz="1400">
                 <a:latin typeface="Consolas"/>
               </a:rPr>
               <a:t>        return children.stream()</a:t>
             </a:r>
           </a:p>
           <a:p>
-            <a:pPr>
-              <a:lnSpc>
-                <a:spcPct val="100000"/>
-              </a:lnSpc>
-              <a:spcBef>
-                <a:spcPts val="0"/>
-              </a:spcBef>
-              <a:spcAft>
-                <a:spcPts val="0"/>
-              </a:spcAft>
-            </a:pPr>
-            <a:r>
-              <a:rPr sz="1200">
+            <a:r>
+              <a:rPr sz="1400">
                 <a:latin typeface="Consolas"/>
               </a:rPr>
               <a:t>            .mapToInt(TariffComponent::getContractCount)</a:t>
             </a:r>
           </a:p>
           <a:p>
-            <a:pPr>
-              <a:lnSpc>
-                <a:spcPct val="100000"/>
-              </a:lnSpc>
-              <a:spcBef>
-                <a:spcPts val="0"/>
-              </a:spcBef>
-              <a:spcAft>
-                <a:spcPts val="0"/>
-              </a:spcAft>
-            </a:pPr>
-            <a:r>
-              <a:rPr sz="1200">
+            <a:r>
+              <a:rPr sz="1400">
                 <a:latin typeface="Consolas"/>
               </a:rPr>
               <a:t>            .sum(); // Rekursive Aggregation</a:t>
             </a:r>
           </a:p>
           <a:p>
-            <a:pPr>
-              <a:lnSpc>
-                <a:spcPct val="100000"/>
-              </a:lnSpc>
-              <a:spcBef>
-                <a:spcPts val="0"/>
-              </a:spcBef>
-              <a:spcAft>
-                <a:spcPts val="0"/>
-              </a:spcAft>
-            </a:pPr>
-            <a:r>
-              <a:rPr sz="1200">
+            <a:r>
+              <a:rPr sz="1400">
                 <a:latin typeface="Consolas"/>
               </a:rPr>
               <a:t>    }</a:t>
             </a:r>
           </a:p>
           <a:p>
-            <a:pPr>
-              <a:lnSpc>
-                <a:spcPct val="100000"/>
-              </a:lnSpc>
-              <a:spcBef>
-                <a:spcPts val="0"/>
-              </a:spcBef>
-              <a:spcAft>
-                <a:spcPts val="0"/>
-              </a:spcAft>
-            </a:pPr>
-            <a:r>
-              <a:rPr sz="1200">
+            <a:r>
+              <a:rPr sz="1400">
                 <a:latin typeface="Consolas"/>
               </a:rPr>
               <a:t>}</a:t>

</xml_diff>